<commit_message>
Update presentation files in Records
Update three presentation files:
- Initial experiment Result.pptx
- Literacture review-followup.pptx
- Literacture review.pptx
</commit_message>
<xml_diff>
--- a/Records/Initial experiment Result.pptx
+++ b/Records/Initial experiment Result.pptx
@@ -142,7 +142,7 @@
 <file path=ppt/revisionInfo.xml><?xml version="1.0" encoding="utf-8"?>
 <p1510:revInfo xmlns:a="http://schemas.openxmlformats.org/drawingml/2006/main" xmlns:r="http://schemas.openxmlformats.org/officeDocument/2006/relationships" xmlns:p1510="http://schemas.microsoft.com/office/powerpoint/2015/10/main">
   <p1510:revLst>
-    <p1510:client id="{CEA52113-AD75-A44D-9117-A960C4FB776B}" v="230" dt="2026-07-14T15:27:57.882"/>
+    <p1510:client id="{CEA52113-AD75-A44D-9117-A960C4FB776B}" v="241" dt="2026-07-21T14:58:28.953"/>
   </p1510:revLst>
 </p1510:revInfo>
 </file>
@@ -152,7 +152,7 @@
   <pc:docChgLst>
     <pc:chgData name="耀泉 马" userId="19e30af8d5659de2" providerId="LiveId" clId="{C3594856-CEDA-5129-B2AF-7962E3CA4CA3}"/>
     <pc:docChg chg="undo custSel addSld delSld modSld sldOrd">
-      <pc:chgData name="耀泉 马" userId="19e30af8d5659de2" providerId="LiveId" clId="{C3594856-CEDA-5129-B2AF-7962E3CA4CA3}" dt="2026-07-14T15:27:57.187" v="6520" actId="20577"/>
+      <pc:chgData name="耀泉 马" userId="19e30af8d5659de2" providerId="LiveId" clId="{C3594856-CEDA-5129-B2AF-7962E3CA4CA3}" dt="2026-07-21T15:53:10.576" v="7005" actId="20577"/>
       <pc:docMkLst>
         <pc:docMk/>
       </pc:docMkLst>
@@ -344,13 +344,6 @@
             <ac:spMk id="31" creationId="{B269ECA1-3868-F3A9-DE85-DD51A2962B9A}"/>
           </ac:spMkLst>
         </pc:spChg>
-      </pc:sldChg>
-      <pc:sldChg chg="modSp new del mod">
-        <pc:chgData name="耀泉 马" userId="19e30af8d5659de2" providerId="LiveId" clId="{C3594856-CEDA-5129-B2AF-7962E3CA4CA3}" dt="2026-07-13T22:11:58.688" v="4007" actId="2696"/>
-        <pc:sldMkLst>
-          <pc:docMk/>
-          <pc:sldMk cId="53360945" sldId="260"/>
-        </pc:sldMkLst>
       </pc:sldChg>
       <pc:sldChg chg="addSp modSp new mod">
         <pc:chgData name="耀泉 马" userId="19e30af8d5659de2" providerId="LiveId" clId="{C3594856-CEDA-5129-B2AF-7962E3CA4CA3}" dt="2026-07-07T08:52:02.854" v="3213" actId="20577"/>
@@ -693,29 +686,6 @@
           </ac:graphicFrameMkLst>
         </pc:graphicFrameChg>
       </pc:sldChg>
-      <pc:sldChg chg="modSp new del mod">
-        <pc:chgData name="耀泉 马" userId="19e30af8d5659de2" providerId="LiveId" clId="{C3594856-CEDA-5129-B2AF-7962E3CA4CA3}" dt="2026-07-13T19:08:04.665" v="3418" actId="2696"/>
-        <pc:sldMkLst>
-          <pc:docMk/>
-          <pc:sldMk cId="1552636674" sldId="274"/>
-        </pc:sldMkLst>
-        <pc:spChg chg="mod">
-          <ac:chgData name="耀泉 马" userId="19e30af8d5659de2" providerId="LiveId" clId="{C3594856-CEDA-5129-B2AF-7962E3CA4CA3}" dt="2026-07-13T19:06:10.994" v="3347"/>
-          <ac:spMkLst>
-            <pc:docMk/>
-            <pc:sldMk cId="1552636674" sldId="274"/>
-            <ac:spMk id="2" creationId="{6988FB34-AE3F-5B39-CAFD-BEF0A95A1903}"/>
-          </ac:spMkLst>
-        </pc:spChg>
-        <pc:spChg chg="mod">
-          <ac:chgData name="耀泉 马" userId="19e30af8d5659de2" providerId="LiveId" clId="{C3594856-CEDA-5129-B2AF-7962E3CA4CA3}" dt="2026-07-13T19:07:32.285" v="3417" actId="20577"/>
-          <ac:spMkLst>
-            <pc:docMk/>
-            <pc:sldMk cId="1552636674" sldId="274"/>
-            <ac:spMk id="3" creationId="{24441C4C-8342-36F0-69F2-CCE953A89809}"/>
-          </ac:spMkLst>
-        </pc:spChg>
-      </pc:sldChg>
       <pc:sldChg chg="add">
         <pc:chgData name="耀泉 马" userId="19e30af8d5659de2" providerId="LiveId" clId="{C3594856-CEDA-5129-B2AF-7962E3CA4CA3}" dt="2026-07-13T19:08:09.881" v="3419"/>
         <pc:sldMkLst>
@@ -737,14 +707,6 @@
             <ac:spMk id="2" creationId="{8DA456CD-C7F4-AF8F-4ECD-C598B4BE52E5}"/>
           </ac:spMkLst>
         </pc:spChg>
-        <pc:spChg chg="del">
-          <ac:chgData name="耀泉 马" userId="19e30af8d5659de2" providerId="LiveId" clId="{C3594856-CEDA-5129-B2AF-7962E3CA4CA3}" dt="2026-07-13T19:19:33.826" v="3435" actId="478"/>
-          <ac:spMkLst>
-            <pc:docMk/>
-            <pc:sldMk cId="211951644" sldId="275"/>
-            <ac:spMk id="3" creationId="{238B8C0E-10B1-1C0B-04BD-F47AE56870D7}"/>
-          </ac:spMkLst>
-        </pc:spChg>
         <pc:spChg chg="add mod">
           <ac:chgData name="耀泉 马" userId="19e30af8d5659de2" providerId="LiveId" clId="{C3594856-CEDA-5129-B2AF-7962E3CA4CA3}" dt="2026-07-13T19:42:22.379" v="3545" actId="1076"/>
           <ac:spMkLst>
@@ -761,28 +723,12 @@
             <ac:spMk id="5" creationId="{6B21A11F-BC19-0AFF-963C-45BBC5BB910A}"/>
           </ac:spMkLst>
         </pc:spChg>
-        <pc:spChg chg="add del mod">
-          <ac:chgData name="耀泉 马" userId="19e30af8d5659de2" providerId="LiveId" clId="{C3594856-CEDA-5129-B2AF-7962E3CA4CA3}" dt="2026-07-13T19:20:00.122" v="3443" actId="22"/>
-          <ac:spMkLst>
-            <pc:docMk/>
-            <pc:sldMk cId="211951644" sldId="275"/>
-            <ac:spMk id="7" creationId="{39029FB2-12E4-12D3-7DBF-69F028C03682}"/>
-          </ac:spMkLst>
-        </pc:spChg>
         <pc:spChg chg="add mod">
           <ac:chgData name="耀泉 马" userId="19e30af8d5659de2" providerId="LiveId" clId="{C3594856-CEDA-5129-B2AF-7962E3CA4CA3}" dt="2026-07-13T19:42:22.379" v="3545" actId="1076"/>
           <ac:spMkLst>
             <pc:docMk/>
             <pc:sldMk cId="211951644" sldId="275"/>
             <ac:spMk id="8" creationId="{EF9AB384-EA17-F2BC-EFBA-45CEFD80D41F}"/>
-          </ac:spMkLst>
-        </pc:spChg>
-        <pc:spChg chg="add del mod">
-          <ac:chgData name="耀泉 马" userId="19e30af8d5659de2" providerId="LiveId" clId="{C3594856-CEDA-5129-B2AF-7962E3CA4CA3}" dt="2026-07-13T19:41:39.602" v="3539" actId="478"/>
-          <ac:spMkLst>
-            <pc:docMk/>
-            <pc:sldMk cId="211951644" sldId="275"/>
-            <ac:spMk id="9" creationId="{FC084115-7C6C-F0AB-1C97-0485F78F513E}"/>
           </ac:spMkLst>
         </pc:spChg>
         <pc:spChg chg="add mod">
@@ -817,48 +763,9 @@
             <ac:spMk id="20" creationId="{818E4094-E178-2188-6B8E-550F8BD4A9B5}"/>
           </ac:spMkLst>
         </pc:spChg>
-        <pc:cxnChg chg="add del mod">
-          <ac:chgData name="耀泉 马" userId="19e30af8d5659de2" providerId="LiveId" clId="{C3594856-CEDA-5129-B2AF-7962E3CA4CA3}" dt="2026-07-13T19:40:04.470" v="3518" actId="478"/>
-          <ac:cxnSpMkLst>
-            <pc:docMk/>
-            <pc:sldMk cId="211951644" sldId="275"/>
-            <ac:cxnSpMk id="11" creationId="{FFC2C331-4897-6A44-0CD5-AE7472E1C974}"/>
-          </ac:cxnSpMkLst>
-        </pc:cxnChg>
-        <pc:cxnChg chg="add del mod">
-          <ac:chgData name="耀泉 马" userId="19e30af8d5659de2" providerId="LiveId" clId="{C3594856-CEDA-5129-B2AF-7962E3CA4CA3}" dt="2026-07-13T19:39:51.468" v="3514" actId="478"/>
-          <ac:cxnSpMkLst>
-            <pc:docMk/>
-            <pc:sldMk cId="211951644" sldId="275"/>
-            <ac:cxnSpMk id="13" creationId="{0869877C-7F24-54B5-7D8C-88AF12485E61}"/>
-          </ac:cxnSpMkLst>
-        </pc:cxnChg>
-      </pc:sldChg>
-      <pc:sldChg chg="modSp add del mod">
-        <pc:chgData name="耀泉 马" userId="19e30af8d5659de2" providerId="LiveId" clId="{C3594856-CEDA-5129-B2AF-7962E3CA4CA3}" dt="2026-07-13T19:08:04.665" v="3418" actId="2696"/>
-        <pc:sldMkLst>
-          <pc:docMk/>
-          <pc:sldMk cId="3501340450" sldId="275"/>
-        </pc:sldMkLst>
-        <pc:spChg chg="mod">
-          <ac:chgData name="耀泉 马" userId="19e30af8d5659de2" providerId="LiveId" clId="{C3594856-CEDA-5129-B2AF-7962E3CA4CA3}" dt="2026-07-13T19:01:39.175" v="3331"/>
-          <ac:spMkLst>
-            <pc:docMk/>
-            <pc:sldMk cId="3501340450" sldId="275"/>
-            <ac:spMk id="2" creationId="{8DA456CD-C7F4-AF8F-4ECD-C598B4BE52E5}"/>
-          </ac:spMkLst>
-        </pc:spChg>
-        <pc:spChg chg="mod">
-          <ac:chgData name="耀泉 马" userId="19e30af8d5659de2" providerId="LiveId" clId="{C3594856-CEDA-5129-B2AF-7962E3CA4CA3}" dt="2026-07-13T19:01:41.126" v="3332" actId="21"/>
-          <ac:spMkLst>
-            <pc:docMk/>
-            <pc:sldMk cId="3501340450" sldId="275"/>
-            <ac:spMk id="3" creationId="{238B8C0E-10B1-1C0B-04BD-F47AE56870D7}"/>
-          </ac:spMkLst>
-        </pc:spChg>
       </pc:sldChg>
       <pc:sldChg chg="addSp delSp modSp add mod">
-        <pc:chgData name="耀泉 马" userId="19e30af8d5659de2" providerId="LiveId" clId="{C3594856-CEDA-5129-B2AF-7962E3CA4CA3}" dt="2026-07-14T15:27:57.187" v="6520" actId="20577"/>
+        <pc:chgData name="耀泉 马" userId="19e30af8d5659de2" providerId="LiveId" clId="{C3594856-CEDA-5129-B2AF-7962E3CA4CA3}" dt="2026-07-21T15:32:59.900" v="6996" actId="20577"/>
         <pc:sldMkLst>
           <pc:docMk/>
           <pc:sldMk cId="1902362840" sldId="276"/>
@@ -871,30 +778,6 @@
             <ac:spMk id="2" creationId="{D11148C6-7523-8D37-B9E3-EB7CD34E958A}"/>
           </ac:spMkLst>
         </pc:spChg>
-        <pc:spChg chg="del">
-          <ac:chgData name="耀泉 马" userId="19e30af8d5659de2" providerId="LiveId" clId="{C3594856-CEDA-5129-B2AF-7962E3CA4CA3}" dt="2026-07-13T20:53:41.613" v="3751" actId="478"/>
-          <ac:spMkLst>
-            <pc:docMk/>
-            <pc:sldMk cId="1902362840" sldId="276"/>
-            <ac:spMk id="4" creationId="{01E56798-9F10-23A0-5C11-A334825710CA}"/>
-          </ac:spMkLst>
-        </pc:spChg>
-        <pc:spChg chg="del">
-          <ac:chgData name="耀泉 马" userId="19e30af8d5659de2" providerId="LiveId" clId="{C3594856-CEDA-5129-B2AF-7962E3CA4CA3}" dt="2026-07-13T20:53:41.613" v="3751" actId="478"/>
-          <ac:spMkLst>
-            <pc:docMk/>
-            <pc:sldMk cId="1902362840" sldId="276"/>
-            <ac:spMk id="5" creationId="{E4D5767D-B97C-BF72-BB44-021904940EA7}"/>
-          </ac:spMkLst>
-        </pc:spChg>
-        <pc:spChg chg="del">
-          <ac:chgData name="耀泉 马" userId="19e30af8d5659de2" providerId="LiveId" clId="{C3594856-CEDA-5129-B2AF-7962E3CA4CA3}" dt="2026-07-13T20:53:41.613" v="3751" actId="478"/>
-          <ac:spMkLst>
-            <pc:docMk/>
-            <pc:sldMk cId="1902362840" sldId="276"/>
-            <ac:spMk id="8" creationId="{67762846-880B-D7A3-6B8A-12587AE4A28C}"/>
-          </ac:spMkLst>
-        </pc:spChg>
         <pc:spChg chg="add mod">
           <ac:chgData name="耀泉 马" userId="19e30af8d5659de2" providerId="LiveId" clId="{C3594856-CEDA-5129-B2AF-7962E3CA4CA3}" dt="2026-07-14T15:27:57.187" v="6520" actId="20577"/>
           <ac:spMkLst>
@@ -903,68 +786,12 @@
             <ac:spMk id="10" creationId="{E54E97B9-9B19-B04E-C501-3396F8164F45}"/>
           </ac:spMkLst>
         </pc:spChg>
-        <pc:spChg chg="del">
-          <ac:chgData name="耀泉 马" userId="19e30af8d5659de2" providerId="LiveId" clId="{C3594856-CEDA-5129-B2AF-7962E3CA4CA3}" dt="2026-07-13T20:53:41.613" v="3751" actId="478"/>
-          <ac:spMkLst>
-            <pc:docMk/>
-            <pc:sldMk cId="1902362840" sldId="276"/>
-            <ac:spMk id="17" creationId="{8C1D5AC1-A78A-7F5A-CA78-357ED30B813C}"/>
-          </ac:spMkLst>
-        </pc:spChg>
-        <pc:spChg chg="del">
-          <ac:chgData name="耀泉 马" userId="19e30af8d5659de2" providerId="LiveId" clId="{C3594856-CEDA-5129-B2AF-7962E3CA4CA3}" dt="2026-07-13T20:53:41.613" v="3751" actId="478"/>
-          <ac:spMkLst>
-            <pc:docMk/>
-            <pc:sldMk cId="1902362840" sldId="276"/>
-            <ac:spMk id="18" creationId="{84849E43-6B6A-BC02-C270-E9C37E84AAF1}"/>
-          </ac:spMkLst>
-        </pc:spChg>
-        <pc:spChg chg="del">
-          <ac:chgData name="耀泉 马" userId="19e30af8d5659de2" providerId="LiveId" clId="{C3594856-CEDA-5129-B2AF-7962E3CA4CA3}" dt="2026-07-13T20:53:41.613" v="3751" actId="478"/>
-          <ac:spMkLst>
-            <pc:docMk/>
-            <pc:sldMk cId="1902362840" sldId="276"/>
-            <ac:spMk id="19" creationId="{6159F4EE-AF46-AD8E-DEFA-39C771D33C7C}"/>
-          </ac:spMkLst>
-        </pc:spChg>
-        <pc:spChg chg="add del mod">
-          <ac:chgData name="耀泉 马" userId="19e30af8d5659de2" providerId="LiveId" clId="{C3594856-CEDA-5129-B2AF-7962E3CA4CA3}" dt="2026-07-13T20:54:14.976" v="3756" actId="3680"/>
-          <ac:spMkLst>
-            <pc:docMk/>
-            <pc:sldMk cId="1902362840" sldId="276"/>
-            <ac:spMk id="20" creationId="{4675CDC8-11E4-945E-B30D-D8E337987B48}"/>
-          </ac:spMkLst>
-        </pc:spChg>
-        <pc:graphicFrameChg chg="add mod">
-          <ac:chgData name="耀泉 马" userId="19e30af8d5659de2" providerId="LiveId" clId="{C3594856-CEDA-5129-B2AF-7962E3CA4CA3}" dt="2026-07-13T20:53:44.486" v="3753"/>
-          <ac:graphicFrameMkLst>
-            <pc:docMk/>
-            <pc:sldMk cId="1902362840" sldId="276"/>
-            <ac:graphicFrameMk id="3" creationId="{E6B1F4FE-9B9D-5B59-F063-80664298AFC1}"/>
-          </ac:graphicFrameMkLst>
-        </pc:graphicFrameChg>
-        <pc:graphicFrameChg chg="add mod">
-          <ac:chgData name="耀泉 马" userId="19e30af8d5659de2" providerId="LiveId" clId="{C3594856-CEDA-5129-B2AF-7962E3CA4CA3}" dt="2026-07-13T20:53:56.881" v="3755"/>
-          <ac:graphicFrameMkLst>
-            <pc:docMk/>
-            <pc:sldMk cId="1902362840" sldId="276"/>
-            <ac:graphicFrameMk id="6" creationId="{90D9F437-8667-1EAE-9234-7521E15A0039}"/>
-          </ac:graphicFrameMkLst>
-        </pc:graphicFrameChg>
         <pc:graphicFrameChg chg="add mod ord modGraphic">
-          <ac:chgData name="耀泉 马" userId="19e30af8d5659de2" providerId="LiveId" clId="{C3594856-CEDA-5129-B2AF-7962E3CA4CA3}" dt="2026-07-14T08:13:25.524" v="4097"/>
+          <ac:chgData name="耀泉 马" userId="19e30af8d5659de2" providerId="LiveId" clId="{C3594856-CEDA-5129-B2AF-7962E3CA4CA3}" dt="2026-07-21T15:32:59.900" v="6996" actId="20577"/>
           <ac:graphicFrameMkLst>
             <pc:docMk/>
             <pc:sldMk cId="1902362840" sldId="276"/>
             <ac:graphicFrameMk id="7" creationId="{F9B04201-DC9C-DFA1-2115-DA2C098352D4}"/>
-          </ac:graphicFrameMkLst>
-        </pc:graphicFrameChg>
-        <pc:graphicFrameChg chg="add mod">
-          <ac:chgData name="耀泉 马" userId="19e30af8d5659de2" providerId="LiveId" clId="{C3594856-CEDA-5129-B2AF-7962E3CA4CA3}" dt="2026-07-13T20:56:51.185" v="3940"/>
-          <ac:graphicFrameMkLst>
-            <pc:docMk/>
-            <pc:sldMk cId="1902362840" sldId="276"/>
-            <ac:graphicFrameMk id="9" creationId="{21B9A361-08B7-0E50-CE2A-4C8DD5036EF4}"/>
           </ac:graphicFrameMkLst>
         </pc:graphicFrameChg>
       </pc:sldChg>
@@ -1013,14 +840,6 @@
             <ac:spMk id="2" creationId="{8E14B777-5CE5-0CCD-FCB6-D2CE0D8EFE59}"/>
           </ac:spMkLst>
         </pc:spChg>
-        <pc:spChg chg="del">
-          <ac:chgData name="耀泉 马" userId="19e30af8d5659de2" providerId="LiveId" clId="{C3594856-CEDA-5129-B2AF-7962E3CA4CA3}" dt="2026-07-14T08:26:04.396" v="4237" actId="3680"/>
-          <ac:spMkLst>
-            <pc:docMk/>
-            <pc:sldMk cId="1153154203" sldId="278"/>
-            <ac:spMk id="3" creationId="{9158539C-6D86-7493-D6CB-F04A7DBE0A94}"/>
-          </ac:spMkLst>
-        </pc:spChg>
         <pc:spChg chg="add mod">
           <ac:chgData name="耀泉 马" userId="19e30af8d5659de2" providerId="LiveId" clId="{C3594856-CEDA-5129-B2AF-7962E3CA4CA3}" dt="2026-07-14T08:28:21.916" v="4367" actId="1076"/>
           <ac:spMkLst>
@@ -1029,67 +848,12 @@
             <ac:spMk id="5" creationId="{854D5AB6-5554-AA65-B260-AA01CAB70968}"/>
           </ac:spMkLst>
         </pc:spChg>
-        <pc:spChg chg="add del mod">
-          <ac:chgData name="耀泉 马" userId="19e30af8d5659de2" providerId="LiveId" clId="{C3594856-CEDA-5129-B2AF-7962E3CA4CA3}" dt="2026-07-14T08:28:17.358" v="4366" actId="21"/>
-          <ac:spMkLst>
-            <pc:docMk/>
-            <pc:sldMk cId="1153154203" sldId="278"/>
-            <ac:spMk id="6" creationId="{21E23250-06FB-8EFA-FD43-9161879C5D5C}"/>
-          </ac:spMkLst>
-        </pc:spChg>
         <pc:graphicFrameChg chg="add mod ord modGraphic">
           <ac:chgData name="耀泉 马" userId="19e30af8d5659de2" providerId="LiveId" clId="{C3594856-CEDA-5129-B2AF-7962E3CA4CA3}" dt="2026-07-14T08:28:21.916" v="4367" actId="1076"/>
           <ac:graphicFrameMkLst>
             <pc:docMk/>
             <pc:sldMk cId="1153154203" sldId="278"/>
             <ac:graphicFrameMk id="4" creationId="{3C9C272F-6B61-5CED-59DF-B0F03E460CA5}"/>
-          </ac:graphicFrameMkLst>
-        </pc:graphicFrameChg>
-      </pc:sldChg>
-      <pc:sldChg chg="addSp modSp new del mod">
-        <pc:chgData name="耀泉 马" userId="19e30af8d5659de2" providerId="LiveId" clId="{C3594856-CEDA-5129-B2AF-7962E3CA4CA3}" dt="2026-07-14T09:38:00.959" v="5119" actId="2696"/>
-        <pc:sldMkLst>
-          <pc:docMk/>
-          <pc:sldMk cId="3620960058" sldId="279"/>
-        </pc:sldMkLst>
-        <pc:spChg chg="mod">
-          <ac:chgData name="耀泉 马" userId="19e30af8d5659de2" providerId="LiveId" clId="{C3594856-CEDA-5129-B2AF-7962E3CA4CA3}" dt="2026-07-14T09:37:31.063" v="5113" actId="1076"/>
-          <ac:spMkLst>
-            <pc:docMk/>
-            <pc:sldMk cId="3620960058" sldId="279"/>
-            <ac:spMk id="2" creationId="{A517D395-AA41-99CD-389B-18CB0A577D5D}"/>
-          </ac:spMkLst>
-        </pc:spChg>
-        <pc:spChg chg="mod">
-          <ac:chgData name="耀泉 马" userId="19e30af8d5659de2" providerId="LiveId" clId="{C3594856-CEDA-5129-B2AF-7962E3CA4CA3}" dt="2026-07-14T09:37:36.111" v="5114" actId="1076"/>
-          <ac:spMkLst>
-            <pc:docMk/>
-            <pc:sldMk cId="3620960058" sldId="279"/>
-            <ac:spMk id="3" creationId="{83D66A77-4D83-A92A-2BD6-31ABA3C24A04}"/>
-          </ac:spMkLst>
-        </pc:spChg>
-        <pc:spChg chg="add mod">
-          <ac:chgData name="耀泉 马" userId="19e30af8d5659de2" providerId="LiveId" clId="{C3594856-CEDA-5129-B2AF-7962E3CA4CA3}" dt="2026-07-14T09:37:36.111" v="5114" actId="1076"/>
-          <ac:spMkLst>
-            <pc:docMk/>
-            <pc:sldMk cId="3620960058" sldId="279"/>
-            <ac:spMk id="6" creationId="{58720DE3-807C-7B2D-5314-D98405E0CA43}"/>
-          </ac:spMkLst>
-        </pc:spChg>
-        <pc:spChg chg="add mod">
-          <ac:chgData name="耀泉 马" userId="19e30af8d5659de2" providerId="LiveId" clId="{C3594856-CEDA-5129-B2AF-7962E3CA4CA3}" dt="2026-07-14T09:37:36.111" v="5114" actId="1076"/>
-          <ac:spMkLst>
-            <pc:docMk/>
-            <pc:sldMk cId="3620960058" sldId="279"/>
-            <ac:spMk id="7" creationId="{C8945295-459F-DF41-6316-EFE25382C2F9}"/>
-          </ac:spMkLst>
-        </pc:spChg>
-        <pc:graphicFrameChg chg="add mod modGraphic">
-          <ac:chgData name="耀泉 马" userId="19e30af8d5659de2" providerId="LiveId" clId="{C3594856-CEDA-5129-B2AF-7962E3CA4CA3}" dt="2026-07-14T09:37:36.111" v="5114" actId="1076"/>
-          <ac:graphicFrameMkLst>
-            <pc:docMk/>
-            <pc:sldMk cId="3620960058" sldId="279"/>
-            <ac:graphicFrameMk id="4" creationId="{F53573C4-FC18-DE0A-D273-4987C3414CEB}"/>
           </ac:graphicFrameMkLst>
         </pc:graphicFrameChg>
       </pc:sldChg>
@@ -1132,85 +896,6 @@
           </ac:graphicFrameMkLst>
         </pc:graphicFrameChg>
       </pc:sldChg>
-      <pc:sldChg chg="addSp delSp modSp add del mod">
-        <pc:chgData name="耀泉 马" userId="19e30af8d5659de2" providerId="LiveId" clId="{C3594856-CEDA-5129-B2AF-7962E3CA4CA3}" dt="2026-07-14T12:13:20.288" v="5327" actId="2696"/>
-        <pc:sldMkLst>
-          <pc:docMk/>
-          <pc:sldMk cId="4188909005" sldId="281"/>
-        </pc:sldMkLst>
-        <pc:spChg chg="mod">
-          <ac:chgData name="耀泉 马" userId="19e30af8d5659de2" providerId="LiveId" clId="{C3594856-CEDA-5129-B2AF-7962E3CA4CA3}" dt="2026-07-14T09:45:00.744" v="5132" actId="20577"/>
-          <ac:spMkLst>
-            <pc:docMk/>
-            <pc:sldMk cId="4188909005" sldId="281"/>
-            <ac:spMk id="2" creationId="{0743BAF4-6747-E9A1-3B3E-ABA3489B73EF}"/>
-          </ac:spMkLst>
-        </pc:spChg>
-        <pc:spChg chg="mod">
-          <ac:chgData name="耀泉 马" userId="19e30af8d5659de2" providerId="LiveId" clId="{C3594856-CEDA-5129-B2AF-7962E3CA4CA3}" dt="2026-07-14T09:48:51.188" v="5147" actId="20577"/>
-          <ac:spMkLst>
-            <pc:docMk/>
-            <pc:sldMk cId="4188909005" sldId="281"/>
-            <ac:spMk id="3" creationId="{952A4125-4E1B-1DE2-EC23-5150D429C9C3}"/>
-          </ac:spMkLst>
-        </pc:spChg>
-        <pc:spChg chg="del">
-          <ac:chgData name="耀泉 马" userId="19e30af8d5659de2" providerId="LiveId" clId="{C3594856-CEDA-5129-B2AF-7962E3CA4CA3}" dt="2026-07-14T09:45:04.437" v="5133" actId="478"/>
-          <ac:spMkLst>
-            <pc:docMk/>
-            <pc:sldMk cId="4188909005" sldId="281"/>
-            <ac:spMk id="6" creationId="{0281D906-1FA5-8BCD-E380-BAF55FC94AE7}"/>
-          </ac:spMkLst>
-        </pc:spChg>
-        <pc:spChg chg="del">
-          <ac:chgData name="耀泉 马" userId="19e30af8d5659de2" providerId="LiveId" clId="{C3594856-CEDA-5129-B2AF-7962E3CA4CA3}" dt="2026-07-14T09:45:06.923" v="5134" actId="478"/>
-          <ac:spMkLst>
-            <pc:docMk/>
-            <pc:sldMk cId="4188909005" sldId="281"/>
-            <ac:spMk id="7" creationId="{F60B63D5-417A-566F-2E00-2C6259AA4A4A}"/>
-          </ac:spMkLst>
-        </pc:spChg>
-        <pc:graphicFrameChg chg="del">
-          <ac:chgData name="耀泉 马" userId="19e30af8d5659de2" providerId="LiveId" clId="{C3594856-CEDA-5129-B2AF-7962E3CA4CA3}" dt="2026-07-14T09:45:39.717" v="5136" actId="478"/>
-          <ac:graphicFrameMkLst>
-            <pc:docMk/>
-            <pc:sldMk cId="4188909005" sldId="281"/>
-            <ac:graphicFrameMk id="4" creationId="{58416CB9-9A89-26D5-1C0E-C11BB6511722}"/>
-          </ac:graphicFrameMkLst>
-        </pc:graphicFrameChg>
-        <pc:graphicFrameChg chg="add mod">
-          <ac:chgData name="耀泉 马" userId="19e30af8d5659de2" providerId="LiveId" clId="{C3594856-CEDA-5129-B2AF-7962E3CA4CA3}" dt="2026-07-14T09:48:02.101" v="5140"/>
-          <ac:graphicFrameMkLst>
-            <pc:docMk/>
-            <pc:sldMk cId="4188909005" sldId="281"/>
-            <ac:graphicFrameMk id="5" creationId="{553F7B0E-31E6-C042-E627-CA7E1690A87A}"/>
-          </ac:graphicFrameMkLst>
-        </pc:graphicFrameChg>
-        <pc:graphicFrameChg chg="add mod">
-          <ac:chgData name="耀泉 马" userId="19e30af8d5659de2" providerId="LiveId" clId="{C3594856-CEDA-5129-B2AF-7962E3CA4CA3}" dt="2026-07-14T09:48:08.164" v="5141"/>
-          <ac:graphicFrameMkLst>
-            <pc:docMk/>
-            <pc:sldMk cId="4188909005" sldId="281"/>
-            <ac:graphicFrameMk id="8" creationId="{DAB02A11-AE3D-16D3-86B9-8A4EBB5856C5}"/>
-          </ac:graphicFrameMkLst>
-        </pc:graphicFrameChg>
-        <pc:graphicFrameChg chg="add del">
-          <ac:chgData name="耀泉 马" userId="19e30af8d5659de2" providerId="LiveId" clId="{C3594856-CEDA-5129-B2AF-7962E3CA4CA3}" dt="2026-07-14T09:48:32.254" v="5143" actId="3680"/>
-          <ac:graphicFrameMkLst>
-            <pc:docMk/>
-            <pc:sldMk cId="4188909005" sldId="281"/>
-            <ac:graphicFrameMk id="9" creationId="{13C5F487-ACF4-80EB-E6FB-DC531901BF1D}"/>
-          </ac:graphicFrameMkLst>
-        </pc:graphicFrameChg>
-        <pc:graphicFrameChg chg="add mod modGraphic">
-          <ac:chgData name="耀泉 马" userId="19e30af8d5659de2" providerId="LiveId" clId="{C3594856-CEDA-5129-B2AF-7962E3CA4CA3}" dt="2026-07-14T09:53:39.111" v="5314" actId="14734"/>
-          <ac:graphicFrameMkLst>
-            <pc:docMk/>
-            <pc:sldMk cId="4188909005" sldId="281"/>
-            <ac:graphicFrameMk id="10" creationId="{EAB2E6A7-2264-535E-FB34-478874EABF50}"/>
-          </ac:graphicFrameMkLst>
-        </pc:graphicFrameChg>
-      </pc:sldChg>
       <pc:sldChg chg="modSp add mod">
         <pc:chgData name="耀泉 马" userId="19e30af8d5659de2" providerId="LiveId" clId="{C3594856-CEDA-5129-B2AF-7962E3CA4CA3}" dt="2026-07-14T13:13:48.783" v="5958" actId="20577"/>
         <pc:sldMkLst>
@@ -1234,21 +919,6 @@
           </ac:graphicFrameMkLst>
         </pc:graphicFrameChg>
       </pc:sldChg>
-      <pc:sldChg chg="modSp new del mod">
-        <pc:chgData name="耀泉 马" userId="19e30af8d5659de2" providerId="LiveId" clId="{C3594856-CEDA-5129-B2AF-7962E3CA4CA3}" dt="2026-07-14T13:57:46.351" v="6275" actId="2696"/>
-        <pc:sldMkLst>
-          <pc:docMk/>
-          <pc:sldMk cId="2674449709" sldId="283"/>
-        </pc:sldMkLst>
-        <pc:spChg chg="mod">
-          <ac:chgData name="耀泉 马" userId="19e30af8d5659de2" providerId="LiveId" clId="{C3594856-CEDA-5129-B2AF-7962E3CA4CA3}" dt="2026-07-14T12:52:29.280" v="5540" actId="20577"/>
-          <ac:spMkLst>
-            <pc:docMk/>
-            <pc:sldMk cId="2674449709" sldId="283"/>
-            <ac:spMk id="2" creationId="{18D087C6-BF2B-22DC-3C42-1785862DAC9A}"/>
-          </ac:spMkLst>
-        </pc:spChg>
-      </pc:sldChg>
       <pc:sldChg chg="addSp delSp modSp add mod">
         <pc:chgData name="耀泉 马" userId="19e30af8d5659de2" providerId="LiveId" clId="{C3594856-CEDA-5129-B2AF-7962E3CA4CA3}" dt="2026-07-14T13:13:45.440" v="5954" actId="20577"/>
         <pc:sldMkLst>
@@ -1261,22 +931,6 @@
             <pc:docMk/>
             <pc:sldMk cId="1206957868" sldId="284"/>
             <ac:spMk id="2" creationId="{79049FFC-C865-C239-D28E-C52D2B741C40}"/>
-          </ac:spMkLst>
-        </pc:spChg>
-        <pc:spChg chg="del mod">
-          <ac:chgData name="耀泉 马" userId="19e30af8d5659de2" providerId="LiveId" clId="{C3594856-CEDA-5129-B2AF-7962E3CA4CA3}" dt="2026-07-14T12:16:09.583" v="5335" actId="478"/>
-          <ac:spMkLst>
-            <pc:docMk/>
-            <pc:sldMk cId="1206957868" sldId="284"/>
-            <ac:spMk id="3" creationId="{1571AE20-3D1C-7EA0-7797-1C38E5CE85D7}"/>
-          </ac:spMkLst>
-        </pc:spChg>
-        <pc:spChg chg="add del mod">
-          <ac:chgData name="耀泉 马" userId="19e30af8d5659de2" providerId="LiveId" clId="{C3594856-CEDA-5129-B2AF-7962E3CA4CA3}" dt="2026-07-14T12:23:44.410" v="5336" actId="3680"/>
-          <ac:spMkLst>
-            <pc:docMk/>
-            <pc:sldMk cId="1206957868" sldId="284"/>
-            <ac:spMk id="5" creationId="{43FA4490-D426-7BFE-28A9-6FBE8281DE49}"/>
           </ac:spMkLst>
         </pc:spChg>
         <pc:spChg chg="add mod">
@@ -1295,21 +949,6 @@
             <ac:graphicFrameMk id="6" creationId="{A8853277-54F8-F7FD-3911-02BDAAD61906}"/>
           </ac:graphicFrameMkLst>
         </pc:graphicFrameChg>
-        <pc:graphicFrameChg chg="del">
-          <ac:chgData name="耀泉 马" userId="19e30af8d5659de2" providerId="LiveId" clId="{C3594856-CEDA-5129-B2AF-7962E3CA4CA3}" dt="2026-07-14T12:16:06.193" v="5334" actId="478"/>
-          <ac:graphicFrameMkLst>
-            <pc:docMk/>
-            <pc:sldMk cId="1206957868" sldId="284"/>
-            <ac:graphicFrameMk id="10" creationId="{93B96854-FF5A-D076-D825-93584DF2F521}"/>
-          </ac:graphicFrameMkLst>
-        </pc:graphicFrameChg>
-      </pc:sldChg>
-      <pc:sldChg chg="add del">
-        <pc:chgData name="耀泉 马" userId="19e30af8d5659de2" providerId="LiveId" clId="{C3594856-CEDA-5129-B2AF-7962E3CA4CA3}" dt="2026-07-14T13:09:22.807" v="5576" actId="2696"/>
-        <pc:sldMkLst>
-          <pc:docMk/>
-          <pc:sldMk cId="624892916" sldId="285"/>
-        </pc:sldMkLst>
       </pc:sldChg>
       <pc:sldChg chg="addSp delSp modSp add mod">
         <pc:chgData name="耀泉 马" userId="19e30af8d5659de2" providerId="LiveId" clId="{C3594856-CEDA-5129-B2AF-7962E3CA4CA3}" dt="2026-07-14T14:00:46.376" v="6296" actId="1076"/>
@@ -1325,68 +964,12 @@
             <ac:spMk id="2" creationId="{B0ADC4F9-2455-C5FA-294C-03DF991C15F5}"/>
           </ac:spMkLst>
         </pc:spChg>
-        <pc:spChg chg="add del mod">
-          <ac:chgData name="耀泉 马" userId="19e30af8d5659de2" providerId="LiveId" clId="{C3594856-CEDA-5129-B2AF-7962E3CA4CA3}" dt="2026-07-14T13:16:09.023" v="5963" actId="3680"/>
-          <ac:spMkLst>
-            <pc:docMk/>
-            <pc:sldMk cId="1696916202" sldId="285"/>
-            <ac:spMk id="4" creationId="{62D61FB8-6DBD-8E1A-663C-7A16CBA88990}"/>
-          </ac:spMkLst>
-        </pc:spChg>
         <pc:spChg chg="mod">
           <ac:chgData name="耀泉 马" userId="19e30af8d5659de2" providerId="LiveId" clId="{C3594856-CEDA-5129-B2AF-7962E3CA4CA3}" dt="2026-07-14T13:15:35.236" v="5961" actId="20577"/>
           <ac:spMkLst>
             <pc:docMk/>
             <pc:sldMk cId="1696916202" sldId="285"/>
             <ac:spMk id="7" creationId="{F59E775D-1005-D65D-954B-C79D7C759849}"/>
-          </ac:spMkLst>
-        </pc:spChg>
-        <pc:spChg chg="add del mod">
-          <ac:chgData name="耀泉 马" userId="19e30af8d5659de2" providerId="LiveId" clId="{C3594856-CEDA-5129-B2AF-7962E3CA4CA3}" dt="2026-07-14T13:51:46.463" v="6162" actId="478"/>
-          <ac:spMkLst>
-            <pc:docMk/>
-            <pc:sldMk cId="1696916202" sldId="285"/>
-            <ac:spMk id="8" creationId="{3DBA26D3-D585-CCE6-09D6-6AE744923908}"/>
-          </ac:spMkLst>
-        </pc:spChg>
-        <pc:spChg chg="add del mod">
-          <ac:chgData name="耀泉 马" userId="19e30af8d5659de2" providerId="LiveId" clId="{C3594856-CEDA-5129-B2AF-7962E3CA4CA3}" dt="2026-07-14T13:51:46.463" v="6162" actId="478"/>
-          <ac:spMkLst>
-            <pc:docMk/>
-            <pc:sldMk cId="1696916202" sldId="285"/>
-            <ac:spMk id="9" creationId="{7A1CEE35-487D-6C0C-68F1-BF6A84450A9E}"/>
-          </ac:spMkLst>
-        </pc:spChg>
-        <pc:spChg chg="add del mod">
-          <ac:chgData name="耀泉 马" userId="19e30af8d5659de2" providerId="LiveId" clId="{C3594856-CEDA-5129-B2AF-7962E3CA4CA3}" dt="2026-07-14T13:51:46.463" v="6162" actId="478"/>
-          <ac:spMkLst>
-            <pc:docMk/>
-            <pc:sldMk cId="1696916202" sldId="285"/>
-            <ac:spMk id="10" creationId="{EE4BFE06-FB1C-8F43-2BB6-B77BD69C42C6}"/>
-          </ac:spMkLst>
-        </pc:spChg>
-        <pc:spChg chg="add del mod">
-          <ac:chgData name="耀泉 马" userId="19e30af8d5659de2" providerId="LiveId" clId="{C3594856-CEDA-5129-B2AF-7962E3CA4CA3}" dt="2026-07-14T13:51:46.463" v="6162" actId="478"/>
-          <ac:spMkLst>
-            <pc:docMk/>
-            <pc:sldMk cId="1696916202" sldId="285"/>
-            <ac:spMk id="11" creationId="{76F63CEC-1543-F3F8-68B8-0E33A6D97BBF}"/>
-          </ac:spMkLst>
-        </pc:spChg>
-        <pc:spChg chg="add del mod">
-          <ac:chgData name="耀泉 马" userId="19e30af8d5659de2" providerId="LiveId" clId="{C3594856-CEDA-5129-B2AF-7962E3CA4CA3}" dt="2026-07-14T13:51:46.463" v="6162" actId="478"/>
-          <ac:spMkLst>
-            <pc:docMk/>
-            <pc:sldMk cId="1696916202" sldId="285"/>
-            <ac:spMk id="12" creationId="{4712E49F-EB4F-2967-7E25-CF814E48E3B3}"/>
-          </ac:spMkLst>
-        </pc:spChg>
-        <pc:spChg chg="add del mod">
-          <ac:chgData name="耀泉 马" userId="19e30af8d5659de2" providerId="LiveId" clId="{C3594856-CEDA-5129-B2AF-7962E3CA4CA3}" dt="2026-07-14T13:51:46.463" v="6162" actId="478"/>
-          <ac:spMkLst>
-            <pc:docMk/>
-            <pc:sldMk cId="1696916202" sldId="285"/>
-            <ac:spMk id="13" creationId="{FA29114E-6133-40FE-FBA0-F16FF7CD355C}"/>
           </ac:spMkLst>
         </pc:spChg>
         <pc:spChg chg="add mod">
@@ -1429,14 +1012,6 @@
             <ac:graphicFrameMk id="5" creationId="{9CCB1254-C9EF-0805-3B3C-121C5080A25C}"/>
           </ac:graphicFrameMkLst>
         </pc:graphicFrameChg>
-        <pc:graphicFrameChg chg="del">
-          <ac:chgData name="耀泉 马" userId="19e30af8d5659de2" providerId="LiveId" clId="{C3594856-CEDA-5129-B2AF-7962E3CA4CA3}" dt="2026-07-14T13:15:38.473" v="5962" actId="478"/>
-          <ac:graphicFrameMkLst>
-            <pc:docMk/>
-            <pc:sldMk cId="1696916202" sldId="285"/>
-            <ac:graphicFrameMk id="6" creationId="{D7343E5A-71FA-881C-F33A-6A24ABAAD9ED}"/>
-          </ac:graphicFrameMkLst>
-        </pc:graphicFrameChg>
       </pc:sldChg>
       <pc:sldChg chg="modSp new mod">
         <pc:chgData name="耀泉 马" userId="19e30af8d5659de2" providerId="LiveId" clId="{C3594856-CEDA-5129-B2AF-7962E3CA4CA3}" dt="2026-07-14T13:13:26.865" v="5948" actId="20577"/>
@@ -1461,8 +1036,8 @@
           </ac:spMkLst>
         </pc:spChg>
       </pc:sldChg>
-      <pc:sldChg chg="modSp new mod">
-        <pc:chgData name="耀泉 马" userId="19e30af8d5659de2" providerId="LiveId" clId="{C3594856-CEDA-5129-B2AF-7962E3CA4CA3}" dt="2026-07-14T15:01:24.393" v="6342" actId="27636"/>
+      <pc:sldChg chg="modSp new mod modNotesTx">
+        <pc:chgData name="耀泉 马" userId="19e30af8d5659de2" providerId="LiveId" clId="{C3594856-CEDA-5129-B2AF-7962E3CA4CA3}" dt="2026-07-21T15:53:10.576" v="7005" actId="20577"/>
         <pc:sldMkLst>
           <pc:docMk/>
           <pc:sldMk cId="650267645" sldId="287"/>
@@ -1476,7 +1051,7 @@
           </ac:spMkLst>
         </pc:spChg>
         <pc:spChg chg="mod">
-          <ac:chgData name="耀泉 马" userId="19e30af8d5659de2" providerId="LiveId" clId="{C3594856-CEDA-5129-B2AF-7962E3CA4CA3}" dt="2026-07-14T15:01:24.393" v="6342" actId="27636"/>
+          <ac:chgData name="耀泉 马" userId="19e30af8d5659de2" providerId="LiveId" clId="{C3594856-CEDA-5129-B2AF-7962E3CA4CA3}" dt="2026-07-21T14:58:53.795" v="6941" actId="113"/>
           <ac:spMkLst>
             <pc:docMk/>
             <pc:sldMk cId="650267645" sldId="287"/>
@@ -1571,7 +1146,7 @@
           <a:p>
             <a:fld id="{31DEB800-E523-5842-ADA5-667D03D4DDAE}" type="datetimeFigureOut">
               <a:rPr lang="en-US" smtClean="0"/>
-              <a:t>7/14/26</a:t>
+              <a:t>7/21/26</a:t>
             </a:fld>
             <a:endParaRPr lang="en-US"/>
           </a:p>
@@ -3161,6 +2736,136 @@
 </p:notes>
 </file>
 
+<file path=ppt/notesSlides/notesSlide21.xml><?xml version="1.0" encoding="utf-8"?>
+<p:notes xmlns:a="http://schemas.openxmlformats.org/drawingml/2006/main" xmlns:r="http://schemas.openxmlformats.org/officeDocument/2006/relationships" xmlns:p="http://schemas.openxmlformats.org/presentationml/2006/main">
+  <p:cSld>
+    <p:spTree>
+      <p:nvGrpSpPr>
+        <p:cNvPr id="1" name=""/>
+        <p:cNvGrpSpPr/>
+        <p:nvPr/>
+      </p:nvGrpSpPr>
+      <p:grpSpPr>
+        <a:xfrm>
+          <a:off x="0" y="0"/>
+          <a:ext cx="0" cy="0"/>
+          <a:chOff x="0" y="0"/>
+          <a:chExt cx="0" cy="0"/>
+        </a:xfrm>
+      </p:grpSpPr>
+      <p:sp>
+        <p:nvSpPr>
+          <p:cNvPr id="2" name="Slide Image Placeholder 1"/>
+          <p:cNvSpPr>
+            <a:spLocks noGrp="1" noRot="1" noChangeAspect="1"/>
+          </p:cNvSpPr>
+          <p:nvPr>
+            <p:ph type="sldImg"/>
+          </p:nvPr>
+        </p:nvSpPr>
+        <p:spPr/>
+      </p:sp>
+      <p:sp>
+        <p:nvSpPr>
+          <p:cNvPr id="3" name="Notes Placeholder 2"/>
+          <p:cNvSpPr>
+            <a:spLocks noGrp="1"/>
+          </p:cNvSpPr>
+          <p:nvPr>
+            <p:ph type="body" idx="1"/>
+          </p:nvPr>
+        </p:nvSpPr>
+        <p:spPr/>
+        <p:txBody>
+          <a:bodyPr/>
+          <a:lstStyle/>
+          <a:p>
+            <a:pPr marL="0" marR="0" lvl="0" indent="0" algn="l" defTabSz="914400" rtl="0" eaLnBrk="1" fontAlgn="auto" latinLnBrk="0" hangingPunct="1">
+              <a:lnSpc>
+                <a:spcPct val="100000"/>
+              </a:lnSpc>
+              <a:spcBef>
+                <a:spcPts val="0"/>
+              </a:spcBef>
+              <a:spcAft>
+                <a:spcPts val="0"/>
+              </a:spcAft>
+              <a:buClrTx/>
+              <a:buSzTx/>
+              <a:buFontTx/>
+              <a:buNone/>
+              <a:tabLst/>
+              <a:defRPr/>
+            </a:pPr>
+            <a:r>
+              <a:rPr lang="en-GB"/>
+              <a:t>We evaluate semantic similarity using </a:t>
+            </a:r>
+            <a:r>
+              <a:rPr lang="en-GB" b="1"/>
+              <a:t>BERTScore</a:t>
+            </a:r>
+            <a:r>
+              <a:rPr lang="en-GB"/>
+              <a:t>, computed with a pre-trained RoBERTa model. No additional training or fine-tuning was performed.</a:t>
+            </a:r>
+          </a:p>
+          <a:p>
+            <a:endParaRPr lang="en-US"/>
+          </a:p>
+          <a:p>
+            <a:endParaRPr lang="en-US"/>
+          </a:p>
+          <a:p>
+            <a:r>
+              <a:rPr lang="en-US"/>
+              <a:t>Weeker?</a:t>
+            </a:r>
+          </a:p>
+          <a:p>
+            <a:endParaRPr lang="en-US"/>
+          </a:p>
+          <a:p>
+            <a:endParaRPr lang="en-US"/>
+          </a:p>
+        </p:txBody>
+      </p:sp>
+      <p:sp>
+        <p:nvSpPr>
+          <p:cNvPr id="4" name="Slide Number Placeholder 3"/>
+          <p:cNvSpPr>
+            <a:spLocks noGrp="1"/>
+          </p:cNvSpPr>
+          <p:nvPr>
+            <p:ph type="sldNum" sz="quarter" idx="5"/>
+          </p:nvPr>
+        </p:nvSpPr>
+        <p:spPr/>
+        <p:txBody>
+          <a:bodyPr/>
+          <a:lstStyle/>
+          <a:p>
+            <a:fld id="{77DADF14-3A71-7E41-BFB5-61D3ACF40C49}" type="slidenum">
+              <a:rPr lang="en-US" smtClean="0"/>
+              <a:t>25</a:t>
+            </a:fld>
+            <a:endParaRPr lang="en-US"/>
+          </a:p>
+        </p:txBody>
+      </p:sp>
+    </p:spTree>
+    <p:extLst>
+      <p:ext uri="{BB962C8B-B14F-4D97-AF65-F5344CB8AC3E}">
+        <p14:creationId xmlns:p14="http://schemas.microsoft.com/office/powerpoint/2010/main" val="1479840301"/>
+      </p:ext>
+    </p:extLst>
+  </p:cSld>
+  <p:clrMapOvr>
+    <a:masterClrMapping/>
+  </p:clrMapOvr>
+</p:notes>
+</file>
+
 <file path=ppt/notesSlides/notesSlide3.xml><?xml version="1.0" encoding="utf-8"?>
 <p:notes xmlns:a="http://schemas.openxmlformats.org/drawingml/2006/main" xmlns:r="http://schemas.openxmlformats.org/officeDocument/2006/relationships" xmlns:p="http://schemas.openxmlformats.org/presentationml/2006/main">
   <p:cSld>
@@ -4223,7 +3928,7 @@
           <a:p>
             <a:fld id="{D13D43DF-0D0E-F847-A925-24D8FAA785A6}" type="datetimeFigureOut">
               <a:rPr lang="en-US" smtClean="0"/>
-              <a:t>7/14/26</a:t>
+              <a:t>7/21/26</a:t>
             </a:fld>
             <a:endParaRPr lang="en-US"/>
           </a:p>
@@ -4423,7 +4128,7 @@
           <a:p>
             <a:fld id="{D13D43DF-0D0E-F847-A925-24D8FAA785A6}" type="datetimeFigureOut">
               <a:rPr lang="en-US" smtClean="0"/>
-              <a:t>7/14/26</a:t>
+              <a:t>7/21/26</a:t>
             </a:fld>
             <a:endParaRPr lang="en-US"/>
           </a:p>
@@ -4633,7 +4338,7 @@
           <a:p>
             <a:fld id="{D13D43DF-0D0E-F847-A925-24D8FAA785A6}" type="datetimeFigureOut">
               <a:rPr lang="en-US" smtClean="0"/>
-              <a:t>7/14/26</a:t>
+              <a:t>7/21/26</a:t>
             </a:fld>
             <a:endParaRPr lang="en-US"/>
           </a:p>
@@ -4833,7 +4538,7 @@
           <a:p>
             <a:fld id="{D13D43DF-0D0E-F847-A925-24D8FAA785A6}" type="datetimeFigureOut">
               <a:rPr lang="en-US" smtClean="0"/>
-              <a:t>7/14/26</a:t>
+              <a:t>7/21/26</a:t>
             </a:fld>
             <a:endParaRPr lang="en-US"/>
           </a:p>
@@ -5109,7 +4814,7 @@
           <a:p>
             <a:fld id="{D13D43DF-0D0E-F847-A925-24D8FAA785A6}" type="datetimeFigureOut">
               <a:rPr lang="en-US" smtClean="0"/>
-              <a:t>7/14/26</a:t>
+              <a:t>7/21/26</a:t>
             </a:fld>
             <a:endParaRPr lang="en-US"/>
           </a:p>
@@ -5377,7 +5082,7 @@
           <a:p>
             <a:fld id="{D13D43DF-0D0E-F847-A925-24D8FAA785A6}" type="datetimeFigureOut">
               <a:rPr lang="en-US" smtClean="0"/>
-              <a:t>7/14/26</a:t>
+              <a:t>7/21/26</a:t>
             </a:fld>
             <a:endParaRPr lang="en-US"/>
           </a:p>
@@ -5792,7 +5497,7 @@
           <a:p>
             <a:fld id="{D13D43DF-0D0E-F847-A925-24D8FAA785A6}" type="datetimeFigureOut">
               <a:rPr lang="en-US" smtClean="0"/>
-              <a:t>7/14/26</a:t>
+              <a:t>7/21/26</a:t>
             </a:fld>
             <a:endParaRPr lang="en-US"/>
           </a:p>
@@ -5934,7 +5639,7 @@
           <a:p>
             <a:fld id="{D13D43DF-0D0E-F847-A925-24D8FAA785A6}" type="datetimeFigureOut">
               <a:rPr lang="en-US" smtClean="0"/>
-              <a:t>7/14/26</a:t>
+              <a:t>7/21/26</a:t>
             </a:fld>
             <a:endParaRPr lang="en-US"/>
           </a:p>
@@ -6047,7 +5752,7 @@
           <a:p>
             <a:fld id="{D13D43DF-0D0E-F847-A925-24D8FAA785A6}" type="datetimeFigureOut">
               <a:rPr lang="en-US" smtClean="0"/>
-              <a:t>7/14/26</a:t>
+              <a:t>7/21/26</a:t>
             </a:fld>
             <a:endParaRPr lang="en-US"/>
           </a:p>
@@ -6360,7 +6065,7 @@
           <a:p>
             <a:fld id="{D13D43DF-0D0E-F847-A925-24D8FAA785A6}" type="datetimeFigureOut">
               <a:rPr lang="en-US" smtClean="0"/>
-              <a:t>7/14/26</a:t>
+              <a:t>7/21/26</a:t>
             </a:fld>
             <a:endParaRPr lang="en-US"/>
           </a:p>
@@ -6649,7 +6354,7 @@
           <a:p>
             <a:fld id="{D13D43DF-0D0E-F847-A925-24D8FAA785A6}" type="datetimeFigureOut">
               <a:rPr lang="en-US" smtClean="0"/>
-              <a:t>7/14/26</a:t>
+              <a:t>7/21/26</a:t>
             </a:fld>
             <a:endParaRPr lang="en-US"/>
           </a:p>
@@ -6892,7 +6597,7 @@
           <a:p>
             <a:fld id="{D13D43DF-0D0E-F847-A925-24D8FAA785A6}" type="datetimeFigureOut">
               <a:rPr lang="en-US" smtClean="0"/>
-              <a:t>7/14/26</a:t>
+              <a:t>7/21/26</a:t>
             </a:fld>
             <a:endParaRPr lang="en-US"/>
           </a:p>
@@ -14605,14 +14310,14 @@
             <p:ph idx="1"/>
             <p:extLst>
               <p:ext uri="{D42A27DB-BD31-4B8C-83A1-F6EECF244321}">
-                <p14:modId xmlns:p14="http://schemas.microsoft.com/office/powerpoint/2010/main" val="864483935"/>
+                <p14:modId xmlns:p14="http://schemas.microsoft.com/office/powerpoint/2010/main" val="733513778"/>
               </p:ext>
             </p:extLst>
           </p:nvPr>
         </p:nvGraphicFramePr>
         <p:xfrm>
           <a:off x="838200" y="1825625"/>
-          <a:ext cx="10515597" cy="2595880"/>
+          <a:ext cx="10781185" cy="2595880"/>
         </p:xfrm>
         <a:graphic>
           <a:graphicData uri="http://schemas.openxmlformats.org/drawingml/2006/table">
@@ -14621,27 +14326,34 @@
                 <a:tableStyleId>{5C22544A-7EE6-4342-B048-85BDC9FD1C3A}</a:tableStyleId>
               </a:tblPr>
               <a:tblGrid>
-                <a:gridCol w="1625301">
+                <a:gridCol w="1329055">
                   <a:extLst>
                     <a:ext uri="{9D8B030D-6E8A-4147-A177-3AD203B41FA5}">
                       <a16:colId xmlns:a16="http://schemas.microsoft.com/office/drawing/2014/main" val="3540850605"/>
                     </a:ext>
                   </a:extLst>
                 </a:gridCol>
-                <a:gridCol w="3334871">
+                <a:gridCol w="3261347">
                   <a:extLst>
                     <a:ext uri="{9D8B030D-6E8A-4147-A177-3AD203B41FA5}">
                       <a16:colId xmlns:a16="http://schemas.microsoft.com/office/drawing/2014/main" val="3226682977"/>
                     </a:ext>
                   </a:extLst>
                 </a:gridCol>
-                <a:gridCol w="5555425">
+                <a:gridCol w="2555755">
                   <a:extLst>
                     <a:ext uri="{9D8B030D-6E8A-4147-A177-3AD203B41FA5}">
                       <a16:colId xmlns:a16="http://schemas.microsoft.com/office/drawing/2014/main" val="3559267260"/>
                     </a:ext>
                   </a:extLst>
                 </a:gridCol>
+                <a:gridCol w="3635028">
+                  <a:extLst>
+                    <a:ext uri="{9D8B030D-6E8A-4147-A177-3AD203B41FA5}">
+                      <a16:colId xmlns:a16="http://schemas.microsoft.com/office/drawing/2014/main" val="2875434147"/>
+                    </a:ext>
+                  </a:extLst>
+                </a:gridCol>
               </a:tblGrid>
               <a:tr h="370840">
                 <a:tc>
@@ -14686,6 +14398,28 @@
                       <a:r>
                         <a:rPr lang="en-US" altLang="zh-CN"/>
                         <a:t>overhead</a:t>
+                      </a:r>
+                      <a:endParaRPr lang="en-US"/>
+                    </a:p>
+                  </a:txBody>
+                  <a:tcPr/>
+                </a:tc>
+                <a:tc>
+                  <a:txBody>
+                    <a:bodyPr/>
+                    <a:lstStyle/>
+                    <a:p>
+                      <a:r>
+                        <a:rPr lang="en-US"/>
+                        <a:t>Encryption</a:t>
+                      </a:r>
+                      <a:r>
+                        <a:rPr lang="zh-CN" altLang="en-US"/>
+                        <a:t> </a:t>
+                      </a:r>
+                      <a:r>
+                        <a:rPr lang="en-US" altLang="zh-CN"/>
+                        <a:t>Overhead</a:t>
                       </a:r>
                       <a:endParaRPr lang="en-US"/>
                     </a:p>
@@ -14741,6 +14475,16 @@
                   </a:txBody>
                   <a:tcPr/>
                 </a:tc>
+                <a:tc>
+                  <a:txBody>
+                    <a:bodyPr/>
+                    <a:lstStyle/>
+                    <a:p>
+                      <a:endParaRPr lang="en-US"/>
+                    </a:p>
+                  </a:txBody>
+                  <a:tcPr/>
+                </a:tc>
                 <a:extLst>
                   <a:ext uri="{0D108BD9-81ED-4DB2-BD59-A6C34878D82A}">
                     <a16:rowId xmlns:a16="http://schemas.microsoft.com/office/drawing/2014/main" val="2362772652"/>
@@ -14790,6 +14534,54 @@
                   </a:txBody>
                   <a:tcPr/>
                 </a:tc>
+                <a:tc>
+                  <a:txBody>
+                    <a:bodyPr/>
+                    <a:lstStyle/>
+                    <a:p>
+                      <a:pPr marL="0" marR="0" lvl="0" indent="0" algn="l" defTabSz="914400" rtl="0" eaLnBrk="1" fontAlgn="auto" latinLnBrk="0" hangingPunct="1">
+                        <a:lnSpc>
+                          <a:spcPct val="100000"/>
+                        </a:lnSpc>
+                        <a:spcBef>
+                          <a:spcPts val="0"/>
+                        </a:spcBef>
+                        <a:spcAft>
+                          <a:spcPts val="0"/>
+                        </a:spcAft>
+                        <a:buClrTx/>
+                        <a:buSzTx/>
+                        <a:buFontTx/>
+                        <a:buNone/>
+                        <a:tabLst/>
+                        <a:defRPr/>
+                      </a:pPr>
+                      <a:r>
+                        <a:rPr lang="en-US" altLang="zh-CN" sz="1800" kern="1200">
+                          <a:solidFill>
+                            <a:schemeClr val="dk1"/>
+                          </a:solidFill>
+                          <a:latin typeface="+mn-lt"/>
+                          <a:ea typeface="+mn-ea"/>
+                          <a:cs typeface="+mn-cs"/>
+                        </a:rPr>
+                        <a:t>+</a:t>
+                      </a:r>
+                      <a:r>
+                        <a:rPr lang="en-GB" sz="1800" kern="1200">
+                          <a:solidFill>
+                            <a:schemeClr val="dk1"/>
+                          </a:solidFill>
+                          <a:latin typeface="+mn-lt"/>
+                          <a:ea typeface="+mn-ea"/>
+                          <a:cs typeface="+mn-cs"/>
+                        </a:rPr>
+                        <a:t>0.204 ms</a:t>
+                      </a:r>
+                    </a:p>
+                  </a:txBody>
+                  <a:tcPr/>
+                </a:tc>
                 <a:extLst>
                   <a:ext uri="{0D108BD9-81ED-4DB2-BD59-A6C34878D82A}">
                     <a16:rowId xmlns:a16="http://schemas.microsoft.com/office/drawing/2014/main" val="1313549323"/>
@@ -14839,6 +14631,54 @@
                   </a:txBody>
                   <a:tcPr/>
                 </a:tc>
+                <a:tc>
+                  <a:txBody>
+                    <a:bodyPr/>
+                    <a:lstStyle/>
+                    <a:p>
+                      <a:pPr marL="0" marR="0" lvl="0" indent="0" algn="l" defTabSz="914400" rtl="0" eaLnBrk="1" fontAlgn="auto" latinLnBrk="0" hangingPunct="1">
+                        <a:lnSpc>
+                          <a:spcPct val="100000"/>
+                        </a:lnSpc>
+                        <a:spcBef>
+                          <a:spcPts val="0"/>
+                        </a:spcBef>
+                        <a:spcAft>
+                          <a:spcPts val="0"/>
+                        </a:spcAft>
+                        <a:buClrTx/>
+                        <a:buSzTx/>
+                        <a:buFontTx/>
+                        <a:buNone/>
+                        <a:tabLst/>
+                        <a:defRPr/>
+                      </a:pPr>
+                      <a:r>
+                        <a:rPr lang="en-US" altLang="zh-CN" sz="1800" kern="1200">
+                          <a:solidFill>
+                            <a:schemeClr val="dk1"/>
+                          </a:solidFill>
+                          <a:latin typeface="+mn-lt"/>
+                          <a:ea typeface="+mn-ea"/>
+                          <a:cs typeface="+mn-cs"/>
+                        </a:rPr>
+                        <a:t>+</a:t>
+                      </a:r>
+                      <a:r>
+                        <a:rPr lang="en-GB" sz="1800" kern="1200">
+                          <a:solidFill>
+                            <a:schemeClr val="dk1"/>
+                          </a:solidFill>
+                          <a:latin typeface="+mn-lt"/>
+                          <a:ea typeface="+mn-ea"/>
+                          <a:cs typeface="+mn-cs"/>
+                        </a:rPr>
+                        <a:t>0.173 ms</a:t>
+                      </a:r>
+                    </a:p>
+                  </a:txBody>
+                  <a:tcPr/>
+                </a:tc>
                 <a:extLst>
                   <a:ext uri="{0D108BD9-81ED-4DB2-BD59-A6C34878D82A}">
                     <a16:rowId xmlns:a16="http://schemas.microsoft.com/office/drawing/2014/main" val="2676279727"/>
@@ -14888,6 +14728,16 @@
                   </a:txBody>
                   <a:tcPr/>
                 </a:tc>
+                <a:tc>
+                  <a:txBody>
+                    <a:bodyPr/>
+                    <a:lstStyle/>
+                    <a:p>
+                      <a:endParaRPr lang="en-US"/>
+                    </a:p>
+                  </a:txBody>
+                  <a:tcPr/>
+                </a:tc>
                 <a:extLst>
                   <a:ext uri="{0D108BD9-81ED-4DB2-BD59-A6C34878D82A}">
                     <a16:rowId xmlns:a16="http://schemas.microsoft.com/office/drawing/2014/main" val="4258721571"/>
@@ -14937,6 +14787,54 @@
                   </a:txBody>
                   <a:tcPr/>
                 </a:tc>
+                <a:tc>
+                  <a:txBody>
+                    <a:bodyPr/>
+                    <a:lstStyle/>
+                    <a:p>
+                      <a:pPr marL="0" marR="0" lvl="0" indent="0" algn="l" defTabSz="914400" rtl="0" eaLnBrk="1" fontAlgn="auto" latinLnBrk="0" hangingPunct="1">
+                        <a:lnSpc>
+                          <a:spcPct val="100000"/>
+                        </a:lnSpc>
+                        <a:spcBef>
+                          <a:spcPts val="0"/>
+                        </a:spcBef>
+                        <a:spcAft>
+                          <a:spcPts val="0"/>
+                        </a:spcAft>
+                        <a:buClrTx/>
+                        <a:buSzTx/>
+                        <a:buFontTx/>
+                        <a:buNone/>
+                        <a:tabLst/>
+                        <a:defRPr/>
+                      </a:pPr>
+                      <a:r>
+                        <a:rPr lang="en-US" altLang="zh-CN" sz="1800" kern="1200">
+                          <a:solidFill>
+                            <a:schemeClr val="dk1"/>
+                          </a:solidFill>
+                          <a:latin typeface="+mn-lt"/>
+                          <a:ea typeface="+mn-ea"/>
+                          <a:cs typeface="+mn-cs"/>
+                        </a:rPr>
+                        <a:t>+</a:t>
+                      </a:r>
+                      <a:r>
+                        <a:rPr lang="en-GB" sz="1800" kern="1200">
+                          <a:solidFill>
+                            <a:schemeClr val="dk1"/>
+                          </a:solidFill>
+                          <a:latin typeface="+mn-lt"/>
+                          <a:ea typeface="+mn-ea"/>
+                          <a:cs typeface="+mn-cs"/>
+                        </a:rPr>
+                        <a:t>0.290 ms</a:t>
+                      </a:r>
+                    </a:p>
+                  </a:txBody>
+                  <a:tcPr/>
+                </a:tc>
                 <a:extLst>
                   <a:ext uri="{0D108BD9-81ED-4DB2-BD59-A6C34878D82A}">
                     <a16:rowId xmlns:a16="http://schemas.microsoft.com/office/drawing/2014/main" val="795387881"/>
@@ -14982,6 +14880,54 @@
                         <a:t>3.548 ms</a:t>
                       </a:r>
                       <a:endParaRPr lang="en-US"/>
+                    </a:p>
+                  </a:txBody>
+                  <a:tcPr/>
+                </a:tc>
+                <a:tc>
+                  <a:txBody>
+                    <a:bodyPr/>
+                    <a:lstStyle/>
+                    <a:p>
+                      <a:pPr marL="0" marR="0" lvl="0" indent="0" algn="l" defTabSz="914400" rtl="0" eaLnBrk="1" fontAlgn="auto" latinLnBrk="0" hangingPunct="1">
+                        <a:lnSpc>
+                          <a:spcPct val="100000"/>
+                        </a:lnSpc>
+                        <a:spcBef>
+                          <a:spcPts val="0"/>
+                        </a:spcBef>
+                        <a:spcAft>
+                          <a:spcPts val="0"/>
+                        </a:spcAft>
+                        <a:buClrTx/>
+                        <a:buSzTx/>
+                        <a:buFontTx/>
+                        <a:buNone/>
+                        <a:tabLst/>
+                        <a:defRPr/>
+                      </a:pPr>
+                      <a:r>
+                        <a:rPr lang="en-US" altLang="zh-CN" sz="1800" kern="1200">
+                          <a:solidFill>
+                            <a:schemeClr val="dk1"/>
+                          </a:solidFill>
+                          <a:latin typeface="+mn-lt"/>
+                          <a:ea typeface="+mn-ea"/>
+                          <a:cs typeface="+mn-cs"/>
+                        </a:rPr>
+                        <a:t>+</a:t>
+                      </a:r>
+                      <a:r>
+                        <a:rPr lang="en-GB" sz="1800" kern="1200">
+                          <a:solidFill>
+                            <a:schemeClr val="dk1"/>
+                          </a:solidFill>
+                          <a:latin typeface="+mn-lt"/>
+                          <a:ea typeface="+mn-ea"/>
+                          <a:cs typeface="+mn-cs"/>
+                        </a:rPr>
+                        <a:t>0.320 ms (0.001s)</a:t>
+                      </a:r>
                     </a:p>
                   </a:txBody>
                   <a:tcPr/>
@@ -20505,7 +20451,7 @@
         </p:spPr>
         <p:txBody>
           <a:bodyPr>
-            <a:normAutofit fontScale="77500" lnSpcReduction="20000"/>
+            <a:normAutofit fontScale="62500" lnSpcReduction="20000"/>
           </a:bodyPr>
           <a:lstStyle/>
           <a:p>
@@ -20551,6 +20497,136 @@
               <a:rPr lang="en-GB"/>
               <a:t>Intel TDX increased end-to-end latency by approximately 4% and cloud inference latency by approximately 9–10%. After EOS-based early stopping, the absolute TEE latency penalty was reduced from approximately 1.4–1.6 seconds to 0.4–0.5 seconds per request.</a:t>
             </a:r>
+          </a:p>
+          <a:p>
+            <a:pPr lvl="1">
+              <a:lnSpc>
+                <a:spcPct val="120000"/>
+              </a:lnSpc>
+            </a:pPr>
+            <a:endParaRPr lang="en-GB"/>
+          </a:p>
+          <a:p>
+            <a:pPr lvl="1">
+              <a:lnSpc>
+                <a:spcPct val="120000"/>
+              </a:lnSpc>
+            </a:pPr>
+            <a:r>
+              <a:rPr lang="en-GB"/>
+              <a:t>AMX</a:t>
+            </a:r>
+            <a:r>
+              <a:rPr lang="en-US" altLang="zh-CN"/>
+              <a:t>,</a:t>
+            </a:r>
+            <a:r>
+              <a:rPr lang="zh-CN" altLang="en-US"/>
+              <a:t> </a:t>
+            </a:r>
+            <a:r>
+              <a:rPr lang="en-US" altLang="zh-CN"/>
+              <a:t>Tcmalloc</a:t>
+            </a:r>
+            <a:r>
+              <a:rPr lang="zh-CN" altLang="en-US"/>
+              <a:t> </a:t>
+            </a:r>
+            <a:r>
+              <a:rPr lang="en-US" altLang="zh-CN"/>
+              <a:t>can be used to reduce the overhead off TEEs.  Can we go deeply?</a:t>
+            </a:r>
+          </a:p>
+          <a:p>
+            <a:pPr lvl="1">
+              <a:lnSpc>
+                <a:spcPct val="120000"/>
+              </a:lnSpc>
+            </a:pPr>
+            <a:r>
+              <a:rPr lang="en-US" altLang="zh-CN"/>
+              <a:t>Use</a:t>
+            </a:r>
+            <a:r>
+              <a:rPr lang="zh-CN" altLang="en-US"/>
+              <a:t> </a:t>
+            </a:r>
+            <a:r>
+              <a:rPr lang="en-US" altLang="zh-CN"/>
+              <a:t>AMX,</a:t>
+            </a:r>
+            <a:r>
+              <a:rPr lang="zh-CN" altLang="en-US"/>
+              <a:t> </a:t>
+            </a:r>
+            <a:r>
+              <a:rPr lang="en-US" altLang="zh-CN"/>
+              <a:t> we need to</a:t>
+            </a:r>
+            <a:r>
+              <a:rPr lang="zh-CN" altLang="en-US"/>
+              <a:t> </a:t>
+            </a:r>
+            <a:r>
+              <a:rPr lang="en-US" altLang="zh-CN"/>
+              <a:t>reduce percision to BF16.</a:t>
+            </a:r>
+          </a:p>
+          <a:p>
+            <a:pPr lvl="1">
+              <a:lnSpc>
+                <a:spcPct val="120000"/>
+              </a:lnSpc>
+            </a:pPr>
+            <a:r>
+              <a:rPr lang="en-GB"/>
+              <a:t>Use AMX, we need to check the accuracy of geneted text.</a:t>
+            </a:r>
+            <a:r>
+              <a:rPr lang="zh-CN" altLang="en-US"/>
+              <a:t> </a:t>
+            </a:r>
+            <a:r>
+              <a:rPr lang="en-US" altLang="zh-CN"/>
+              <a:t>(</a:t>
+            </a:r>
+            <a:r>
+              <a:rPr lang="en-GB"/>
+              <a:t>Exact Match </a:t>
+            </a:r>
+            <a:r>
+              <a:rPr lang="en-US" altLang="zh-CN"/>
+              <a:t>?</a:t>
+            </a:r>
+            <a:r>
+              <a:rPr lang="zh-CN" altLang="en-US"/>
+              <a:t> </a:t>
+            </a:r>
+            <a:r>
+              <a:rPr lang="en-GB"/>
+              <a:t>BERT</a:t>
+            </a:r>
+            <a:r>
+              <a:rPr lang="zh-CN" altLang="en-US"/>
+              <a:t> </a:t>
+            </a:r>
+            <a:r>
+              <a:rPr lang="en-GB"/>
+              <a:t>Score </a:t>
+            </a:r>
+            <a:r>
+              <a:rPr lang="en-US" altLang="zh-CN"/>
+              <a:t>?)</a:t>
+            </a:r>
+            <a:endParaRPr lang="en-GB"/>
+          </a:p>
+          <a:p>
+            <a:pPr lvl="1">
+              <a:lnSpc>
+                <a:spcPct val="120000"/>
+              </a:lnSpc>
+            </a:pPr>
+            <a:endParaRPr lang="en-GB"/>
           </a:p>
           <a:p>
             <a:pPr>

</xml_diff>

<commit_message>
Update Initial experiment result powerpoint
</commit_message>
<xml_diff>
--- a/Records/Initial experiment Result.pptx
+++ b/Records/Initial experiment Result.pptx
@@ -142,7 +142,7 @@
 <file path=ppt/revisionInfo.xml><?xml version="1.0" encoding="utf-8"?>
 <p1510:revInfo xmlns:a="http://schemas.openxmlformats.org/drawingml/2006/main" xmlns:r="http://schemas.openxmlformats.org/officeDocument/2006/relationships" xmlns:p1510="http://schemas.microsoft.com/office/powerpoint/2015/10/main">
   <p1510:revLst>
-    <p1510:client id="{CEA52113-AD75-A44D-9117-A960C4FB776B}" v="241" dt="2026-07-21T14:58:28.953"/>
+    <p1510:client id="{CEA52113-AD75-A44D-9117-A960C4FB776B}" v="242" dt="2026-08-14T15:38:38.619"/>
   </p1510:revLst>
 </p1510:revInfo>
 </file>
@@ -152,416 +152,18 @@
   <pc:docChgLst>
     <pc:chgData name="耀泉 马" userId="19e30af8d5659de2" providerId="LiveId" clId="{C3594856-CEDA-5129-B2AF-7962E3CA4CA3}"/>
     <pc:docChg chg="undo custSel addSld delSld modSld sldOrd">
-      <pc:chgData name="耀泉 马" userId="19e30af8d5659de2" providerId="LiveId" clId="{C3594856-CEDA-5129-B2AF-7962E3CA4CA3}" dt="2026-07-21T15:53:10.576" v="7005" actId="20577"/>
+      <pc:chgData name="耀泉 马" userId="19e30af8d5659de2" providerId="LiveId" clId="{C3594856-CEDA-5129-B2AF-7962E3CA4CA3}" dt="2026-08-14T15:38:38.617" v="7017" actId="20578"/>
       <pc:docMkLst>
         <pc:docMk/>
       </pc:docMkLst>
-      <pc:sldChg chg="modSp mod">
-        <pc:chgData name="耀泉 马" userId="19e30af8d5659de2" providerId="LiveId" clId="{C3594856-CEDA-5129-B2AF-7962E3CA4CA3}" dt="2026-07-14T15:02:28.400" v="6346" actId="113"/>
-        <pc:sldMkLst>
-          <pc:docMk/>
-          <pc:sldMk cId="46466474" sldId="256"/>
-        </pc:sldMkLst>
-        <pc:spChg chg="mod">
-          <ac:chgData name="耀泉 马" userId="19e30af8d5659de2" providerId="LiveId" clId="{C3594856-CEDA-5129-B2AF-7962E3CA4CA3}" dt="2026-07-06T12:36:34.999" v="549" actId="27636"/>
-          <ac:spMkLst>
-            <pc:docMk/>
-            <pc:sldMk cId="46466474" sldId="256"/>
-            <ac:spMk id="2" creationId="{7C242083-3667-FCF0-CDA8-01809AE9F55A}"/>
-          </ac:spMkLst>
-        </pc:spChg>
-        <pc:spChg chg="mod">
-          <ac:chgData name="耀泉 马" userId="19e30af8d5659de2" providerId="LiveId" clId="{C3594856-CEDA-5129-B2AF-7962E3CA4CA3}" dt="2026-07-14T15:02:28.400" v="6346" actId="113"/>
-          <ac:spMkLst>
-            <pc:docMk/>
-            <pc:sldMk cId="46466474" sldId="256"/>
-            <ac:spMk id="3" creationId="{B9D89D5C-9A33-CDDA-A70A-790326EB583B}"/>
-          </ac:spMkLst>
-        </pc:spChg>
-      </pc:sldChg>
-      <pc:sldChg chg="modSp mod ord">
-        <pc:chgData name="耀泉 马" userId="19e30af8d5659de2" providerId="LiveId" clId="{C3594856-CEDA-5129-B2AF-7962E3CA4CA3}" dt="2026-07-07T06:03:45.496" v="2842"/>
-        <pc:sldMkLst>
-          <pc:docMk/>
-          <pc:sldMk cId="4075704444" sldId="257"/>
-        </pc:sldMkLst>
-        <pc:graphicFrameChg chg="mod modGraphic">
-          <ac:chgData name="耀泉 马" userId="19e30af8d5659de2" providerId="LiveId" clId="{C3594856-CEDA-5129-B2AF-7962E3CA4CA3}" dt="2026-07-07T06:03:45.496" v="2842"/>
-          <ac:graphicFrameMkLst>
-            <pc:docMk/>
-            <pc:sldMk cId="4075704444" sldId="257"/>
-            <ac:graphicFrameMk id="4" creationId="{C02EC1EC-9FF0-E0B7-692C-574FC8CEA821}"/>
-          </ac:graphicFrameMkLst>
-        </pc:graphicFrameChg>
-      </pc:sldChg>
-      <pc:sldChg chg="addSp delSp modSp mod ord">
-        <pc:chgData name="耀泉 马" userId="19e30af8d5659de2" providerId="LiveId" clId="{C3594856-CEDA-5129-B2AF-7962E3CA4CA3}" dt="2026-07-07T06:04:15.654" v="2879" actId="20577"/>
-        <pc:sldMkLst>
-          <pc:docMk/>
-          <pc:sldMk cId="35631109" sldId="258"/>
-        </pc:sldMkLst>
-        <pc:spChg chg="mod">
-          <ac:chgData name="耀泉 马" userId="19e30af8d5659de2" providerId="LiveId" clId="{C3594856-CEDA-5129-B2AF-7962E3CA4CA3}" dt="2026-07-04T14:19:44.832" v="7" actId="20577"/>
-          <ac:spMkLst>
-            <pc:docMk/>
-            <pc:sldMk cId="35631109" sldId="258"/>
-            <ac:spMk id="2" creationId="{DE1BEF8D-5B9A-A461-B4B9-BE6B52756531}"/>
-          </ac:spMkLst>
-        </pc:spChg>
-        <pc:spChg chg="mod">
-          <ac:chgData name="耀泉 马" userId="19e30af8d5659de2" providerId="LiveId" clId="{C3594856-CEDA-5129-B2AF-7962E3CA4CA3}" dt="2026-07-07T06:04:15.654" v="2879" actId="20577"/>
-          <ac:spMkLst>
-            <pc:docMk/>
-            <pc:sldMk cId="35631109" sldId="258"/>
-            <ac:spMk id="3" creationId="{7308112B-78EA-B635-2E18-42DE708C5642}"/>
-          </ac:spMkLst>
-        </pc:spChg>
-        <pc:spChg chg="add mod">
-          <ac:chgData name="耀泉 马" userId="19e30af8d5659de2" providerId="LiveId" clId="{C3594856-CEDA-5129-B2AF-7962E3CA4CA3}" dt="2026-07-06T14:14:44.068" v="934" actId="1076"/>
-          <ac:spMkLst>
-            <pc:docMk/>
-            <pc:sldMk cId="35631109" sldId="258"/>
-            <ac:spMk id="4" creationId="{12239E8C-D8EE-2B21-9CB2-FB1E597D8FB7}"/>
-          </ac:spMkLst>
-        </pc:spChg>
-        <pc:spChg chg="add mod">
-          <ac:chgData name="耀泉 马" userId="19e30af8d5659de2" providerId="LiveId" clId="{C3594856-CEDA-5129-B2AF-7962E3CA4CA3}" dt="2026-07-06T14:15:02.780" v="966" actId="1038"/>
-          <ac:spMkLst>
-            <pc:docMk/>
-            <pc:sldMk cId="35631109" sldId="258"/>
-            <ac:spMk id="5" creationId="{D0E85236-7C36-AF79-4F95-200D02A74E16}"/>
-          </ac:spMkLst>
-        </pc:spChg>
-        <pc:spChg chg="add mod">
-          <ac:chgData name="耀泉 马" userId="19e30af8d5659de2" providerId="LiveId" clId="{C3594856-CEDA-5129-B2AF-7962E3CA4CA3}" dt="2026-07-06T14:20:34.760" v="1066" actId="1035"/>
-          <ac:spMkLst>
-            <pc:docMk/>
-            <pc:sldMk cId="35631109" sldId="258"/>
-            <ac:spMk id="7" creationId="{569B8972-F4B3-9E1C-4430-981EA905D146}"/>
-          </ac:spMkLst>
-        </pc:spChg>
-        <pc:spChg chg="add mod">
-          <ac:chgData name="耀泉 马" userId="19e30af8d5659de2" providerId="LiveId" clId="{C3594856-CEDA-5129-B2AF-7962E3CA4CA3}" dt="2026-07-06T15:49:13.824" v="2125" actId="1038"/>
-          <ac:spMkLst>
-            <pc:docMk/>
-            <pc:sldMk cId="35631109" sldId="258"/>
-            <ac:spMk id="8" creationId="{AF556C30-8722-4273-C5C6-F61CDC835ABC}"/>
-          </ac:spMkLst>
-        </pc:spChg>
-        <pc:spChg chg="add mod">
-          <ac:chgData name="耀泉 马" userId="19e30af8d5659de2" providerId="LiveId" clId="{C3594856-CEDA-5129-B2AF-7962E3CA4CA3}" dt="2026-07-06T14:15:28.150" v="971" actId="1076"/>
-          <ac:spMkLst>
-            <pc:docMk/>
-            <pc:sldMk cId="35631109" sldId="258"/>
-            <ac:spMk id="9" creationId="{78A8CBE9-8B46-90A3-6BA9-91A9B5BFD674}"/>
-          </ac:spMkLst>
-        </pc:spChg>
-        <pc:spChg chg="add mod">
-          <ac:chgData name="耀泉 马" userId="19e30af8d5659de2" providerId="LiveId" clId="{C3594856-CEDA-5129-B2AF-7962E3CA4CA3}" dt="2026-07-06T14:22:44.368" v="1082" actId="20577"/>
-          <ac:spMkLst>
-            <pc:docMk/>
-            <pc:sldMk cId="35631109" sldId="258"/>
-            <ac:spMk id="10" creationId="{6FC709C1-D3E0-3425-8645-D5811D63DA71}"/>
-          </ac:spMkLst>
-        </pc:spChg>
-        <pc:spChg chg="add mod">
-          <ac:chgData name="耀泉 马" userId="19e30af8d5659de2" providerId="LiveId" clId="{C3594856-CEDA-5129-B2AF-7962E3CA4CA3}" dt="2026-07-06T15:48:57.262" v="2120" actId="1035"/>
-          <ac:spMkLst>
-            <pc:docMk/>
-            <pc:sldMk cId="35631109" sldId="258"/>
-            <ac:spMk id="11" creationId="{8C0981B3-04A1-09DA-BAB5-4C1D711F7E34}"/>
-          </ac:spMkLst>
-        </pc:spChg>
-        <pc:spChg chg="add mod">
-          <ac:chgData name="耀泉 马" userId="19e30af8d5659de2" providerId="LiveId" clId="{C3594856-CEDA-5129-B2AF-7962E3CA4CA3}" dt="2026-07-06T15:49:02.992" v="2121" actId="1076"/>
-          <ac:spMkLst>
-            <pc:docMk/>
-            <pc:sldMk cId="35631109" sldId="258"/>
-            <ac:spMk id="12" creationId="{AF15392F-D543-55F4-1311-F5D1DF641C04}"/>
-          </ac:spMkLst>
-        </pc:spChg>
-        <pc:spChg chg="add mod">
-          <ac:chgData name="耀泉 马" userId="19e30af8d5659de2" providerId="LiveId" clId="{C3594856-CEDA-5129-B2AF-7962E3CA4CA3}" dt="2026-07-06T14:21:39.843" v="1073" actId="21"/>
-          <ac:spMkLst>
-            <pc:docMk/>
-            <pc:sldMk cId="35631109" sldId="258"/>
-            <ac:spMk id="13" creationId="{90ABF085-94B6-006B-E77C-025FE4DA7610}"/>
-          </ac:spMkLst>
-        </pc:spChg>
-        <pc:spChg chg="add mod">
-          <ac:chgData name="耀泉 马" userId="19e30af8d5659de2" providerId="LiveId" clId="{C3594856-CEDA-5129-B2AF-7962E3CA4CA3}" dt="2026-07-06T14:33:35.629" v="1257" actId="20577"/>
-          <ac:spMkLst>
-            <pc:docMk/>
-            <pc:sldMk cId="35631109" sldId="258"/>
-            <ac:spMk id="14" creationId="{6A681C7B-24C2-3FAC-53A3-1970569B4FBE}"/>
-          </ac:spMkLst>
-        </pc:spChg>
-        <pc:spChg chg="add mod">
-          <ac:chgData name="耀泉 马" userId="19e30af8d5659de2" providerId="LiveId" clId="{C3594856-CEDA-5129-B2AF-7962E3CA4CA3}" dt="2026-07-06T14:31:47.127" v="1252" actId="207"/>
-          <ac:spMkLst>
-            <pc:docMk/>
-            <pc:sldMk cId="35631109" sldId="258"/>
-            <ac:spMk id="16" creationId="{13F391ED-FA9A-15C2-E972-D961EDB46546}"/>
-          </ac:spMkLst>
-        </pc:spChg>
-        <pc:spChg chg="add mod">
-          <ac:chgData name="耀泉 马" userId="19e30af8d5659de2" providerId="LiveId" clId="{C3594856-CEDA-5129-B2AF-7962E3CA4CA3}" dt="2026-07-06T14:47:00.990" v="1515" actId="1036"/>
-          <ac:spMkLst>
-            <pc:docMk/>
-            <pc:sldMk cId="35631109" sldId="258"/>
-            <ac:spMk id="26" creationId="{583CDFCC-2E3C-6890-3666-71CB9CF639B9}"/>
-          </ac:spMkLst>
-        </pc:spChg>
-        <pc:spChg chg="add mod">
-          <ac:chgData name="耀泉 马" userId="19e30af8d5659de2" providerId="LiveId" clId="{C3594856-CEDA-5129-B2AF-7962E3CA4CA3}" dt="2026-07-06T14:47:00.990" v="1515" actId="1036"/>
-          <ac:spMkLst>
-            <pc:docMk/>
-            <pc:sldMk cId="35631109" sldId="258"/>
-            <ac:spMk id="27" creationId="{D1E9DF30-6B9C-E037-0CE0-4DB953788253}"/>
-          </ac:spMkLst>
-        </pc:spChg>
-        <pc:spChg chg="add mod">
-          <ac:chgData name="耀泉 马" userId="19e30af8d5659de2" providerId="LiveId" clId="{C3594856-CEDA-5129-B2AF-7962E3CA4CA3}" dt="2026-07-06T14:47:00.990" v="1515" actId="1036"/>
-          <ac:spMkLst>
-            <pc:docMk/>
-            <pc:sldMk cId="35631109" sldId="258"/>
-            <ac:spMk id="28" creationId="{A4591EA8-8662-0AAE-E784-A640267FA77D}"/>
-          </ac:spMkLst>
-        </pc:spChg>
-        <pc:spChg chg="add mod">
-          <ac:chgData name="耀泉 马" userId="19e30af8d5659de2" providerId="LiveId" clId="{C3594856-CEDA-5129-B2AF-7962E3CA4CA3}" dt="2026-07-06T14:47:00.990" v="1515" actId="1036"/>
-          <ac:spMkLst>
-            <pc:docMk/>
-            <pc:sldMk cId="35631109" sldId="258"/>
-            <ac:spMk id="29" creationId="{5B05EF8C-FCC8-62DB-C1EE-DA432BE13104}"/>
-          </ac:spMkLst>
-        </pc:spChg>
-        <pc:spChg chg="add mod">
-          <ac:chgData name="耀泉 马" userId="19e30af8d5659de2" providerId="LiveId" clId="{C3594856-CEDA-5129-B2AF-7962E3CA4CA3}" dt="2026-07-06T14:47:00.990" v="1515" actId="1036"/>
-          <ac:spMkLst>
-            <pc:docMk/>
-            <pc:sldMk cId="35631109" sldId="258"/>
-            <ac:spMk id="31" creationId="{B269ECA1-3868-F3A9-DE85-DD51A2962B9A}"/>
-          </ac:spMkLst>
-        </pc:spChg>
-      </pc:sldChg>
-      <pc:sldChg chg="addSp modSp new mod">
-        <pc:chgData name="耀泉 马" userId="19e30af8d5659de2" providerId="LiveId" clId="{C3594856-CEDA-5129-B2AF-7962E3CA4CA3}" dt="2026-07-07T08:52:02.854" v="3213" actId="20577"/>
-        <pc:sldMkLst>
-          <pc:docMk/>
-          <pc:sldMk cId="995147252" sldId="261"/>
-        </pc:sldMkLst>
-        <pc:spChg chg="mod">
-          <ac:chgData name="耀泉 马" userId="19e30af8d5659de2" providerId="LiveId" clId="{C3594856-CEDA-5129-B2AF-7962E3CA4CA3}" dt="2026-07-07T08:52:02.854" v="3213" actId="20577"/>
-          <ac:spMkLst>
-            <pc:docMk/>
-            <pc:sldMk cId="995147252" sldId="261"/>
-            <ac:spMk id="2" creationId="{55C1FA44-6518-D491-231E-5C210026D9DD}"/>
-          </ac:spMkLst>
-        </pc:spChg>
-        <pc:spChg chg="mod">
-          <ac:chgData name="耀泉 马" userId="19e30af8d5659de2" providerId="LiveId" clId="{C3594856-CEDA-5129-B2AF-7962E3CA4CA3}" dt="2026-07-07T05:15:54.836" v="2659" actId="20577"/>
-          <ac:spMkLst>
-            <pc:docMk/>
-            <pc:sldMk cId="995147252" sldId="261"/>
-            <ac:spMk id="3" creationId="{D9C9F56C-6339-EAB7-E2B2-93D86532DF89}"/>
-          </ac:spMkLst>
-        </pc:spChg>
-        <pc:spChg chg="add mod">
-          <ac:chgData name="耀泉 马" userId="19e30af8d5659de2" providerId="LiveId" clId="{C3594856-CEDA-5129-B2AF-7962E3CA4CA3}" dt="2026-07-06T13:00:30.311" v="594" actId="14100"/>
-          <ac:spMkLst>
-            <pc:docMk/>
-            <pc:sldMk cId="995147252" sldId="261"/>
-            <ac:spMk id="4" creationId="{658CD96B-3D57-C90F-0289-2787945FF76C}"/>
-          </ac:spMkLst>
-        </pc:spChg>
-        <pc:spChg chg="add mod">
-          <ac:chgData name="耀泉 马" userId="19e30af8d5659de2" providerId="LiveId" clId="{C3594856-CEDA-5129-B2AF-7962E3CA4CA3}" dt="2026-07-06T13:00:32.879" v="595" actId="1076"/>
-          <ac:spMkLst>
-            <pc:docMk/>
-            <pc:sldMk cId="995147252" sldId="261"/>
-            <ac:spMk id="5" creationId="{F9EA4119-B15C-9896-4B50-A9E39BA50D81}"/>
-          </ac:spMkLst>
-        </pc:spChg>
-      </pc:sldChg>
-      <pc:sldChg chg="addSp delSp modSp new mod">
-        <pc:chgData name="耀泉 马" userId="19e30af8d5659de2" providerId="LiveId" clId="{C3594856-CEDA-5129-B2AF-7962E3CA4CA3}" dt="2026-07-07T08:23:46.651" v="3131" actId="20577"/>
-        <pc:sldMkLst>
-          <pc:docMk/>
-          <pc:sldMk cId="4098136001" sldId="264"/>
-        </pc:sldMkLst>
-        <pc:spChg chg="mod">
-          <ac:chgData name="耀泉 马" userId="19e30af8d5659de2" providerId="LiveId" clId="{C3594856-CEDA-5129-B2AF-7962E3CA4CA3}" dt="2026-07-06T13:19:34.220" v="873" actId="27636"/>
-          <ac:spMkLst>
-            <pc:docMk/>
-            <pc:sldMk cId="4098136001" sldId="264"/>
-            <ac:spMk id="2" creationId="{6D056841-C9EB-B1C5-E51E-01418EEB1C48}"/>
-          </ac:spMkLst>
-        </pc:spChg>
-        <pc:spChg chg="add mod">
-          <ac:chgData name="耀泉 马" userId="19e30af8d5659de2" providerId="LiveId" clId="{C3594856-CEDA-5129-B2AF-7962E3CA4CA3}" dt="2026-07-07T05:20:34.158" v="2663"/>
-          <ac:spMkLst>
-            <pc:docMk/>
-            <pc:sldMk cId="4098136001" sldId="264"/>
-            <ac:spMk id="9" creationId="{65B5DB0D-49F0-8D60-F6D9-04E68885F5FF}"/>
-          </ac:spMkLst>
-        </pc:spChg>
-        <pc:graphicFrameChg chg="add mod ord modGraphic">
-          <ac:chgData name="耀泉 马" userId="19e30af8d5659de2" providerId="LiveId" clId="{C3594856-CEDA-5129-B2AF-7962E3CA4CA3}" dt="2026-07-07T08:23:46.651" v="3131" actId="20577"/>
-          <ac:graphicFrameMkLst>
-            <pc:docMk/>
-            <pc:sldMk cId="4098136001" sldId="264"/>
-            <ac:graphicFrameMk id="6" creationId="{61ABFF60-EC8A-3DEB-4C41-381E0DB5F554}"/>
-          </ac:graphicFrameMkLst>
-        </pc:graphicFrameChg>
-      </pc:sldChg>
-      <pc:sldChg chg="addSp delSp modSp new mod modNotesTx">
-        <pc:chgData name="耀泉 马" userId="19e30af8d5659de2" providerId="LiveId" clId="{C3594856-CEDA-5129-B2AF-7962E3CA4CA3}" dt="2026-07-07T08:29:04.175" v="3138" actId="20577"/>
-        <pc:sldMkLst>
-          <pc:docMk/>
-          <pc:sldMk cId="729314180" sldId="265"/>
-        </pc:sldMkLst>
-        <pc:spChg chg="mod">
-          <ac:chgData name="耀泉 马" userId="19e30af8d5659de2" providerId="LiveId" clId="{C3594856-CEDA-5129-B2AF-7962E3CA4CA3}" dt="2026-07-06T15:42:47.308" v="1956" actId="20577"/>
-          <ac:spMkLst>
-            <pc:docMk/>
-            <pc:sldMk cId="729314180" sldId="265"/>
-            <ac:spMk id="2" creationId="{1E70FCC8-E417-02CA-FDB0-A68799994E02}"/>
-          </ac:spMkLst>
-        </pc:spChg>
-        <pc:graphicFrameChg chg="add mod ord modGraphic">
-          <ac:chgData name="耀泉 马" userId="19e30af8d5659de2" providerId="LiveId" clId="{C3594856-CEDA-5129-B2AF-7962E3CA4CA3}" dt="2026-07-07T08:27:44.537" v="3136" actId="20577"/>
-          <ac:graphicFrameMkLst>
-            <pc:docMk/>
-            <pc:sldMk cId="729314180" sldId="265"/>
-            <ac:graphicFrameMk id="4" creationId="{FDDD12B8-C530-2800-ADF7-22D0FE6F6619}"/>
-          </ac:graphicFrameMkLst>
-        </pc:graphicFrameChg>
-      </pc:sldChg>
-      <pc:sldChg chg="modSp add mod modNotesTx">
-        <pc:chgData name="耀泉 马" userId="19e30af8d5659de2" providerId="LiveId" clId="{C3594856-CEDA-5129-B2AF-7962E3CA4CA3}" dt="2026-07-07T06:35:05.272" v="2976"/>
-        <pc:sldMkLst>
-          <pc:docMk/>
-          <pc:sldMk cId="1369336720" sldId="266"/>
-        </pc:sldMkLst>
-        <pc:spChg chg="mod">
-          <ac:chgData name="耀泉 马" userId="19e30af8d5659de2" providerId="LiveId" clId="{C3594856-CEDA-5129-B2AF-7962E3CA4CA3}" dt="2026-07-07T06:10:59.122" v="2890" actId="20577"/>
-          <ac:spMkLst>
-            <pc:docMk/>
-            <pc:sldMk cId="1369336720" sldId="266"/>
-            <ac:spMk id="2" creationId="{0AD31E1F-4DC1-E802-793B-E81DE612C316}"/>
-          </ac:spMkLst>
-        </pc:spChg>
-        <pc:graphicFrameChg chg="mod modGraphic">
-          <ac:chgData name="耀泉 马" userId="19e30af8d5659de2" providerId="LiveId" clId="{C3594856-CEDA-5129-B2AF-7962E3CA4CA3}" dt="2026-07-07T06:35:05.272" v="2976"/>
-          <ac:graphicFrameMkLst>
-            <pc:docMk/>
-            <pc:sldMk cId="1369336720" sldId="266"/>
-            <ac:graphicFrameMk id="4" creationId="{954E03B5-1DE7-31B9-E397-7DFA3548B25B}"/>
-          </ac:graphicFrameMkLst>
-        </pc:graphicFrameChg>
-      </pc:sldChg>
-      <pc:sldChg chg="addSp modSp new mod modNotesTx">
-        <pc:chgData name="耀泉 马" userId="19e30af8d5659de2" providerId="LiveId" clId="{C3594856-CEDA-5129-B2AF-7962E3CA4CA3}" dt="2026-07-07T05:56:16.394" v="2838" actId="20577"/>
-        <pc:sldMkLst>
-          <pc:docMk/>
-          <pc:sldMk cId="843060192" sldId="267"/>
-        </pc:sldMkLst>
-        <pc:spChg chg="mod">
-          <ac:chgData name="耀泉 马" userId="19e30af8d5659de2" providerId="LiveId" clId="{C3594856-CEDA-5129-B2AF-7962E3CA4CA3}" dt="2026-07-06T15:48:36.556" v="2118" actId="20577"/>
-          <ac:spMkLst>
-            <pc:docMk/>
-            <pc:sldMk cId="843060192" sldId="267"/>
-            <ac:spMk id="2" creationId="{D032DAA5-9D7D-7892-E745-7D2A1F30F67D}"/>
-          </ac:spMkLst>
-        </pc:spChg>
-        <pc:spChg chg="mod">
-          <ac:chgData name="耀泉 马" userId="19e30af8d5659de2" providerId="LiveId" clId="{C3594856-CEDA-5129-B2AF-7962E3CA4CA3}" dt="2026-07-07T05:56:16.394" v="2838" actId="20577"/>
-          <ac:spMkLst>
-            <pc:docMk/>
-            <pc:sldMk cId="843060192" sldId="267"/>
-            <ac:spMk id="3" creationId="{BFE19E9F-E266-AE5D-5498-A94CB0208C7F}"/>
-          </ac:spMkLst>
-        </pc:spChg>
-        <pc:graphicFrameChg chg="add mod modGraphic">
-          <ac:chgData name="耀泉 马" userId="19e30af8d5659de2" providerId="LiveId" clId="{C3594856-CEDA-5129-B2AF-7962E3CA4CA3}" dt="2026-07-07T05:48:33.520" v="2809" actId="20577"/>
-          <ac:graphicFrameMkLst>
-            <pc:docMk/>
-            <pc:sldMk cId="843060192" sldId="267"/>
-            <ac:graphicFrameMk id="4" creationId="{ECFA8844-C062-716A-2D62-AB5CFBEC373B}"/>
-          </ac:graphicFrameMkLst>
-        </pc:graphicFrameChg>
-      </pc:sldChg>
-      <pc:sldChg chg="addSp delSp modSp add mod modNotesTx">
-        <pc:chgData name="耀泉 马" userId="19e30af8d5659de2" providerId="LiveId" clId="{C3594856-CEDA-5129-B2AF-7962E3CA4CA3}" dt="2026-07-07T08:36:55.055" v="3202" actId="20577"/>
-        <pc:sldMkLst>
-          <pc:docMk/>
-          <pc:sldMk cId="3984260910" sldId="268"/>
-        </pc:sldMkLst>
-        <pc:spChg chg="mod">
-          <ac:chgData name="耀泉 马" userId="19e30af8d5659de2" providerId="LiveId" clId="{C3594856-CEDA-5129-B2AF-7962E3CA4CA3}" dt="2026-07-06T22:26:55.045" v="2367" actId="1076"/>
-          <ac:spMkLst>
-            <pc:docMk/>
-            <pc:sldMk cId="3984260910" sldId="268"/>
-            <ac:spMk id="2" creationId="{9E298A0A-2212-5E0B-7D74-5E4496CAC571}"/>
-          </ac:spMkLst>
-        </pc:spChg>
-        <pc:spChg chg="add mod">
-          <ac:chgData name="耀泉 马" userId="19e30af8d5659de2" providerId="LiveId" clId="{C3594856-CEDA-5129-B2AF-7962E3CA4CA3}" dt="2026-07-06T22:26:59.681" v="2368" actId="1076"/>
-          <ac:spMkLst>
-            <pc:docMk/>
-            <pc:sldMk cId="3984260910" sldId="268"/>
-            <ac:spMk id="5" creationId="{52370DF7-7FB4-BD29-799E-82A6E08A8E69}"/>
-          </ac:spMkLst>
-        </pc:spChg>
-        <pc:spChg chg="add mod">
-          <ac:chgData name="耀泉 马" userId="19e30af8d5659de2" providerId="LiveId" clId="{C3594856-CEDA-5129-B2AF-7962E3CA4CA3}" dt="2026-07-06T22:27:07.430" v="2371" actId="14100"/>
-          <ac:spMkLst>
-            <pc:docMk/>
-            <pc:sldMk cId="3984260910" sldId="268"/>
-            <ac:spMk id="8" creationId="{8B9D4C5E-C541-4AE9-F56D-19CD2E0A10FC}"/>
-          </ac:spMkLst>
-        </pc:spChg>
-        <pc:graphicFrameChg chg="add mod modGraphic">
-          <ac:chgData name="耀泉 马" userId="19e30af8d5659de2" providerId="LiveId" clId="{C3594856-CEDA-5129-B2AF-7962E3CA4CA3}" dt="2026-07-07T08:30:34.832" v="3193" actId="20577"/>
-          <ac:graphicFrameMkLst>
-            <pc:docMk/>
-            <pc:sldMk cId="3984260910" sldId="268"/>
-            <ac:graphicFrameMk id="6" creationId="{5D6D8649-71AD-C152-F318-84BAC9D00373}"/>
-          </ac:graphicFrameMkLst>
-        </pc:graphicFrameChg>
-      </pc:sldChg>
-      <pc:sldChg chg="addSp delSp modSp new mod modNotesTx">
-        <pc:chgData name="耀泉 马" userId="19e30af8d5659de2" providerId="LiveId" clId="{C3594856-CEDA-5129-B2AF-7962E3CA4CA3}" dt="2026-07-07T08:40:51.260" v="3212" actId="20577"/>
-        <pc:sldMkLst>
-          <pc:docMk/>
-          <pc:sldMk cId="3987597944" sldId="269"/>
-        </pc:sldMkLst>
-        <pc:spChg chg="mod">
-          <ac:chgData name="耀泉 马" userId="19e30af8d5659de2" providerId="LiveId" clId="{C3594856-CEDA-5129-B2AF-7962E3CA4CA3}" dt="2026-07-07T06:11:02.570" v="2895" actId="20577"/>
-          <ac:spMkLst>
-            <pc:docMk/>
-            <pc:sldMk cId="3987597944" sldId="269"/>
-            <ac:spMk id="2" creationId="{2DF856F0-5759-69BE-CE0E-C7C075FD5D08}"/>
-          </ac:spMkLst>
-        </pc:spChg>
-        <pc:graphicFrameChg chg="add mod modGraphic">
-          <ac:chgData name="耀泉 马" userId="19e30af8d5659de2" providerId="LiveId" clId="{C3594856-CEDA-5129-B2AF-7962E3CA4CA3}" dt="2026-07-06T22:53:03.514" v="2655"/>
-          <ac:graphicFrameMkLst>
-            <pc:docMk/>
-            <pc:sldMk cId="3987597944" sldId="269"/>
-            <ac:graphicFrameMk id="4" creationId="{10467F80-6FE1-AAA0-5934-C061F3323B4C}"/>
-          </ac:graphicFrameMkLst>
-        </pc:graphicFrameChg>
-      </pc:sldChg>
       <pc:sldChg chg="addSp delSp modSp new mod setBg">
-        <pc:chgData name="耀泉 马" userId="19e30af8d5659de2" providerId="LiveId" clId="{C3594856-CEDA-5129-B2AF-7962E3CA4CA3}" dt="2026-07-07T06:53:28.869" v="2985" actId="26606"/>
+        <pc:chgData name="耀泉 马" userId="19e30af8d5659de2" providerId="LiveId" clId="{C3594856-CEDA-5129-B2AF-7962E3CA4CA3}" dt="2026-08-13T07:59:49.319" v="7016" actId="20577"/>
         <pc:sldMkLst>
           <pc:docMk/>
           <pc:sldMk cId="3182603622" sldId="270"/>
         </pc:sldMkLst>
-        <pc:graphicFrameChg chg="add mod">
-          <ac:chgData name="耀泉 马" userId="19e30af8d5659de2" providerId="LiveId" clId="{C3594856-CEDA-5129-B2AF-7962E3CA4CA3}" dt="2026-07-07T06:53:28.869" v="2985" actId="26606"/>
+        <pc:graphicFrameChg chg="add mod modGraphic">
+          <ac:chgData name="耀泉 马" userId="19e30af8d5659de2" providerId="LiveId" clId="{C3594856-CEDA-5129-B2AF-7962E3CA4CA3}" dt="2026-08-13T07:59:49.319" v="7016" actId="20577"/>
           <ac:graphicFrameMkLst>
             <pc:docMk/>
             <pc:sldMk cId="3182603622" sldId="270"/>
@@ -569,223 +171,12 @@
           </ac:graphicFrameMkLst>
         </pc:graphicFrameChg>
       </pc:sldChg>
-      <pc:sldChg chg="addSp delSp modSp new mod setBg">
-        <pc:chgData name="耀泉 马" userId="19e30af8d5659de2" providerId="LiveId" clId="{C3594856-CEDA-5129-B2AF-7962E3CA4CA3}" dt="2026-07-07T07:06:55.074" v="3107" actId="20577"/>
-        <pc:sldMkLst>
-          <pc:docMk/>
-          <pc:sldMk cId="3029205287" sldId="271"/>
-        </pc:sldMkLst>
-        <pc:spChg chg="mod">
-          <ac:chgData name="耀泉 马" userId="19e30af8d5659de2" providerId="LiveId" clId="{C3594856-CEDA-5129-B2AF-7962E3CA4CA3}" dt="2026-07-07T07:06:55.074" v="3107" actId="20577"/>
-          <ac:spMkLst>
-            <pc:docMk/>
-            <pc:sldMk cId="3029205287" sldId="271"/>
-            <ac:spMk id="2" creationId="{FE310519-7DB3-8B15-FDE6-83961ADC5753}"/>
-          </ac:spMkLst>
-        </pc:spChg>
-        <pc:spChg chg="add">
-          <ac:chgData name="耀泉 马" userId="19e30af8d5659de2" providerId="LiveId" clId="{C3594856-CEDA-5129-B2AF-7962E3CA4CA3}" dt="2026-07-07T07:04:27.283" v="3088" actId="26606"/>
-          <ac:spMkLst>
-            <pc:docMk/>
-            <pc:sldMk cId="3029205287" sldId="271"/>
-            <ac:spMk id="18" creationId="{BCED4D40-4B67-4331-AC48-79B82B4A47D8}"/>
-          </ac:spMkLst>
-        </pc:spChg>
-        <pc:spChg chg="add">
-          <ac:chgData name="耀泉 马" userId="19e30af8d5659de2" providerId="LiveId" clId="{C3594856-CEDA-5129-B2AF-7962E3CA4CA3}" dt="2026-07-07T07:04:27.283" v="3088" actId="26606"/>
-          <ac:spMkLst>
-            <pc:docMk/>
-            <pc:sldMk cId="3029205287" sldId="271"/>
-            <ac:spMk id="20" creationId="{670CEDEF-4F34-412E-84EE-329C1E936AF5}"/>
-          </ac:spMkLst>
-        </pc:spChg>
-        <pc:graphicFrameChg chg="add mod modGraphic">
-          <ac:chgData name="耀泉 马" userId="19e30af8d5659de2" providerId="LiveId" clId="{C3594856-CEDA-5129-B2AF-7962E3CA4CA3}" dt="2026-07-07T07:04:27.283" v="3088" actId="26606"/>
-          <ac:graphicFrameMkLst>
-            <pc:docMk/>
-            <pc:sldMk cId="3029205287" sldId="271"/>
-            <ac:graphicFrameMk id="4" creationId="{E0EF4C3C-51A6-7822-E573-4247207C59FD}"/>
-          </ac:graphicFrameMkLst>
-        </pc:graphicFrameChg>
-      </pc:sldChg>
-      <pc:sldChg chg="addSp delSp modSp new mod setBg">
-        <pc:chgData name="耀泉 马" userId="19e30af8d5659de2" providerId="LiveId" clId="{C3594856-CEDA-5129-B2AF-7962E3CA4CA3}" dt="2026-07-07T07:06:50.998" v="3106" actId="20577"/>
-        <pc:sldMkLst>
-          <pc:docMk/>
-          <pc:sldMk cId="2973739318" sldId="272"/>
-        </pc:sldMkLst>
-        <pc:spChg chg="mod">
-          <ac:chgData name="耀泉 马" userId="19e30af8d5659de2" providerId="LiveId" clId="{C3594856-CEDA-5129-B2AF-7962E3CA4CA3}" dt="2026-07-07T07:06:50.998" v="3106" actId="20577"/>
-          <ac:spMkLst>
-            <pc:docMk/>
-            <pc:sldMk cId="2973739318" sldId="272"/>
-            <ac:spMk id="2" creationId="{3B97CE99-2782-252B-1086-278D83E2CC13}"/>
-          </ac:spMkLst>
-        </pc:spChg>
-        <pc:spChg chg="add">
-          <ac:chgData name="耀泉 马" userId="19e30af8d5659de2" providerId="LiveId" clId="{C3594856-CEDA-5129-B2AF-7962E3CA4CA3}" dt="2026-07-07T07:04:23.080" v="3087" actId="26606"/>
-          <ac:spMkLst>
-            <pc:docMk/>
-            <pc:sldMk cId="2973739318" sldId="272"/>
-            <ac:spMk id="9" creationId="{BCED4D40-4B67-4331-AC48-79B82B4A47D8}"/>
-          </ac:spMkLst>
-        </pc:spChg>
-        <pc:spChg chg="add">
-          <ac:chgData name="耀泉 马" userId="19e30af8d5659de2" providerId="LiveId" clId="{C3594856-CEDA-5129-B2AF-7962E3CA4CA3}" dt="2026-07-07T07:04:23.080" v="3087" actId="26606"/>
-          <ac:spMkLst>
-            <pc:docMk/>
-            <pc:sldMk cId="2973739318" sldId="272"/>
-            <ac:spMk id="11" creationId="{670CEDEF-4F34-412E-84EE-329C1E936AF5}"/>
-          </ac:spMkLst>
-        </pc:spChg>
-        <pc:graphicFrameChg chg="add mod modGraphic">
-          <ac:chgData name="耀泉 马" userId="19e30af8d5659de2" providerId="LiveId" clId="{C3594856-CEDA-5129-B2AF-7962E3CA4CA3}" dt="2026-07-07T07:04:23.080" v="3087" actId="26606"/>
-          <ac:graphicFrameMkLst>
-            <pc:docMk/>
-            <pc:sldMk cId="2973739318" sldId="272"/>
-            <ac:graphicFrameMk id="4" creationId="{4D855A2E-63D8-8C9A-A2DB-6D57E155C7D2}"/>
-          </ac:graphicFrameMkLst>
-        </pc:graphicFrameChg>
-      </pc:sldChg>
-      <pc:sldChg chg="addSp delSp modSp new mod setBg modNotesTx">
-        <pc:chgData name="耀泉 马" userId="19e30af8d5659de2" providerId="LiveId" clId="{C3594856-CEDA-5129-B2AF-7962E3CA4CA3}" dt="2026-07-07T07:09:37.086" v="3115" actId="20577"/>
-        <pc:sldMkLst>
-          <pc:docMk/>
-          <pc:sldMk cId="1406360658" sldId="273"/>
-        </pc:sldMkLst>
-        <pc:spChg chg="mod">
-          <ac:chgData name="耀泉 马" userId="19e30af8d5659de2" providerId="LiveId" clId="{C3594856-CEDA-5129-B2AF-7962E3CA4CA3}" dt="2026-07-07T07:07:04.097" v="3109" actId="1076"/>
-          <ac:spMkLst>
-            <pc:docMk/>
-            <pc:sldMk cId="1406360658" sldId="273"/>
-            <ac:spMk id="2" creationId="{D6B8BFDA-D843-0DBC-ABF2-72EB79FCAB53}"/>
-          </ac:spMkLst>
-        </pc:spChg>
-        <pc:spChg chg="add">
-          <ac:chgData name="耀泉 马" userId="19e30af8d5659de2" providerId="LiveId" clId="{C3594856-CEDA-5129-B2AF-7962E3CA4CA3}" dt="2026-07-07T07:06:29.441" v="3104" actId="26606"/>
-          <ac:spMkLst>
-            <pc:docMk/>
-            <pc:sldMk cId="1406360658" sldId="273"/>
-            <ac:spMk id="22" creationId="{C59AB4C8-9178-4F7A-8404-6890510B5917}"/>
-          </ac:spMkLst>
-        </pc:spChg>
-        <pc:spChg chg="add">
-          <ac:chgData name="耀泉 马" userId="19e30af8d5659de2" providerId="LiveId" clId="{C3594856-CEDA-5129-B2AF-7962E3CA4CA3}" dt="2026-07-07T07:06:29.441" v="3104" actId="26606"/>
-          <ac:spMkLst>
-            <pc:docMk/>
-            <pc:sldMk cId="1406360658" sldId="273"/>
-            <ac:spMk id="24" creationId="{4CFDFB37-4BC7-42C6-915D-A6609139BFE7}"/>
-          </ac:spMkLst>
-        </pc:spChg>
-        <pc:graphicFrameChg chg="add mod modGraphic">
-          <ac:chgData name="耀泉 马" userId="19e30af8d5659de2" providerId="LiveId" clId="{C3594856-CEDA-5129-B2AF-7962E3CA4CA3}" dt="2026-07-07T07:07:24.012" v="3114" actId="1076"/>
-          <ac:graphicFrameMkLst>
-            <pc:docMk/>
-            <pc:sldMk cId="1406360658" sldId="273"/>
-            <ac:graphicFrameMk id="4" creationId="{AEC26B20-D474-CDC3-2CF4-FC146E61D01C}"/>
-          </ac:graphicFrameMkLst>
-        </pc:graphicFrameChg>
-      </pc:sldChg>
-      <pc:sldChg chg="add">
-        <pc:chgData name="耀泉 马" userId="19e30af8d5659de2" providerId="LiveId" clId="{C3594856-CEDA-5129-B2AF-7962E3CA4CA3}" dt="2026-07-13T19:08:09.881" v="3419"/>
-        <pc:sldMkLst>
-          <pc:docMk/>
-          <pc:sldMk cId="3308869977" sldId="274"/>
-        </pc:sldMkLst>
-      </pc:sldChg>
-      <pc:sldChg chg="addSp delSp modSp add mod">
-        <pc:chgData name="耀泉 马" userId="19e30af8d5659de2" providerId="LiveId" clId="{C3594856-CEDA-5129-B2AF-7962E3CA4CA3}" dt="2026-07-13T19:50:41.115" v="3749" actId="255"/>
-        <pc:sldMkLst>
-          <pc:docMk/>
-          <pc:sldMk cId="211951644" sldId="275"/>
-        </pc:sldMkLst>
-        <pc:spChg chg="mod">
-          <ac:chgData name="耀泉 马" userId="19e30af8d5659de2" providerId="LiveId" clId="{C3594856-CEDA-5129-B2AF-7962E3CA4CA3}" dt="2026-07-13T19:47:58.319" v="3602" actId="20577"/>
-          <ac:spMkLst>
-            <pc:docMk/>
-            <pc:sldMk cId="211951644" sldId="275"/>
-            <ac:spMk id="2" creationId="{8DA456CD-C7F4-AF8F-4ECD-C598B4BE52E5}"/>
-          </ac:spMkLst>
-        </pc:spChg>
-        <pc:spChg chg="add mod">
-          <ac:chgData name="耀泉 马" userId="19e30af8d5659de2" providerId="LiveId" clId="{C3594856-CEDA-5129-B2AF-7962E3CA4CA3}" dt="2026-07-13T19:42:22.379" v="3545" actId="1076"/>
-          <ac:spMkLst>
-            <pc:docMk/>
-            <pc:sldMk cId="211951644" sldId="275"/>
-            <ac:spMk id="4" creationId="{F09D3B43-04F7-AA12-C85F-50EA5DD2B225}"/>
-          </ac:spMkLst>
-        </pc:spChg>
-        <pc:spChg chg="add mod">
-          <ac:chgData name="耀泉 马" userId="19e30af8d5659de2" providerId="LiveId" clId="{C3594856-CEDA-5129-B2AF-7962E3CA4CA3}" dt="2026-07-13T19:42:22.379" v="3545" actId="1076"/>
-          <ac:spMkLst>
-            <pc:docMk/>
-            <pc:sldMk cId="211951644" sldId="275"/>
-            <ac:spMk id="5" creationId="{6B21A11F-BC19-0AFF-963C-45BBC5BB910A}"/>
-          </ac:spMkLst>
-        </pc:spChg>
-        <pc:spChg chg="add mod">
-          <ac:chgData name="耀泉 马" userId="19e30af8d5659de2" providerId="LiveId" clId="{C3594856-CEDA-5129-B2AF-7962E3CA4CA3}" dt="2026-07-13T19:42:22.379" v="3545" actId="1076"/>
-          <ac:spMkLst>
-            <pc:docMk/>
-            <pc:sldMk cId="211951644" sldId="275"/>
-            <ac:spMk id="8" creationId="{EF9AB384-EA17-F2BC-EFBA-45CEFD80D41F}"/>
-          </ac:spMkLst>
-        </pc:spChg>
-        <pc:spChg chg="add mod">
-          <ac:chgData name="耀泉 马" userId="19e30af8d5659de2" providerId="LiveId" clId="{C3594856-CEDA-5129-B2AF-7962E3CA4CA3}" dt="2026-07-13T19:42:22.379" v="3545" actId="1076"/>
-          <ac:spMkLst>
-            <pc:docMk/>
-            <pc:sldMk cId="211951644" sldId="275"/>
-            <ac:spMk id="17" creationId="{FD5AA771-4334-E207-2F97-82F1D10C0CE7}"/>
-          </ac:spMkLst>
-        </pc:spChg>
-        <pc:spChg chg="add mod">
-          <ac:chgData name="耀泉 马" userId="19e30af8d5659de2" providerId="LiveId" clId="{C3594856-CEDA-5129-B2AF-7962E3CA4CA3}" dt="2026-07-13T19:42:22.379" v="3545" actId="1076"/>
-          <ac:spMkLst>
-            <pc:docMk/>
-            <pc:sldMk cId="211951644" sldId="275"/>
-            <ac:spMk id="18" creationId="{8EC62EA4-D46F-A180-A61F-33A6B17C1CDA}"/>
-          </ac:spMkLst>
-        </pc:spChg>
-        <pc:spChg chg="add mod">
-          <ac:chgData name="耀泉 马" userId="19e30af8d5659de2" providerId="LiveId" clId="{C3594856-CEDA-5129-B2AF-7962E3CA4CA3}" dt="2026-07-13T19:42:22.379" v="3545" actId="1076"/>
-          <ac:spMkLst>
-            <pc:docMk/>
-            <pc:sldMk cId="211951644" sldId="275"/>
-            <ac:spMk id="19" creationId="{AAB79CF3-5F53-F5D5-9845-871A9BE96599}"/>
-          </ac:spMkLst>
-        </pc:spChg>
-        <pc:spChg chg="add mod">
-          <ac:chgData name="耀泉 马" userId="19e30af8d5659de2" providerId="LiveId" clId="{C3594856-CEDA-5129-B2AF-7962E3CA4CA3}" dt="2026-07-13T19:50:41.115" v="3749" actId="255"/>
-          <ac:spMkLst>
-            <pc:docMk/>
-            <pc:sldMk cId="211951644" sldId="275"/>
-            <ac:spMk id="20" creationId="{818E4094-E178-2188-6B8E-550F8BD4A9B5}"/>
-          </ac:spMkLst>
-        </pc:spChg>
-      </pc:sldChg>
       <pc:sldChg chg="addSp delSp modSp add mod">
         <pc:chgData name="耀泉 马" userId="19e30af8d5659de2" providerId="LiveId" clId="{C3594856-CEDA-5129-B2AF-7962E3CA4CA3}" dt="2026-07-21T15:32:59.900" v="6996" actId="20577"/>
         <pc:sldMkLst>
           <pc:docMk/>
           <pc:sldMk cId="1902362840" sldId="276"/>
         </pc:sldMkLst>
-        <pc:spChg chg="mod">
-          <ac:chgData name="耀泉 马" userId="19e30af8d5659de2" providerId="LiveId" clId="{C3594856-CEDA-5129-B2AF-7962E3CA4CA3}" dt="2026-07-13T20:59:31.925" v="3994"/>
-          <ac:spMkLst>
-            <pc:docMk/>
-            <pc:sldMk cId="1902362840" sldId="276"/>
-            <ac:spMk id="2" creationId="{D11148C6-7523-8D37-B9E3-EB7CD34E958A}"/>
-          </ac:spMkLst>
-        </pc:spChg>
-        <pc:spChg chg="add mod">
-          <ac:chgData name="耀泉 马" userId="19e30af8d5659de2" providerId="LiveId" clId="{C3594856-CEDA-5129-B2AF-7962E3CA4CA3}" dt="2026-07-14T15:27:57.187" v="6520" actId="20577"/>
-          <ac:spMkLst>
-            <pc:docMk/>
-            <pc:sldMk cId="1902362840" sldId="276"/>
-            <ac:spMk id="10" creationId="{E54E97B9-9B19-B04E-C501-3396F8164F45}"/>
-          </ac:spMkLst>
-        </pc:spChg>
         <pc:graphicFrameChg chg="add mod ord modGraphic">
           <ac:chgData name="耀泉 马" userId="19e30af8d5659de2" providerId="LiveId" clId="{C3594856-CEDA-5129-B2AF-7962E3CA4CA3}" dt="2026-07-21T15:32:59.900" v="6996" actId="20577"/>
           <ac:graphicFrameMkLst>
@@ -795,244 +186,18 @@
           </ac:graphicFrameMkLst>
         </pc:graphicFrameChg>
       </pc:sldChg>
-      <pc:sldChg chg="modSp add mod modNotesTx">
-        <pc:chgData name="耀泉 马" userId="19e30af8d5659de2" providerId="LiveId" clId="{C3594856-CEDA-5129-B2AF-7962E3CA4CA3}" dt="2026-07-14T08:20:02.751" v="4232" actId="20577"/>
-        <pc:sldMkLst>
-          <pc:docMk/>
-          <pc:sldMk cId="3569115401" sldId="277"/>
-        </pc:sldMkLst>
-        <pc:spChg chg="mod">
-          <ac:chgData name="耀泉 马" userId="19e30af8d5659de2" providerId="LiveId" clId="{C3594856-CEDA-5129-B2AF-7962E3CA4CA3}" dt="2026-07-14T08:16:03.871" v="4163"/>
-          <ac:spMkLst>
-            <pc:docMk/>
-            <pc:sldMk cId="3569115401" sldId="277"/>
-            <ac:spMk id="2" creationId="{4508F06B-76BB-98EA-5066-B1F17D044321}"/>
-          </ac:spMkLst>
-        </pc:spChg>
-        <pc:spChg chg="mod">
-          <ac:chgData name="耀泉 马" userId="19e30af8d5659de2" providerId="LiveId" clId="{C3594856-CEDA-5129-B2AF-7962E3CA4CA3}" dt="2026-07-14T08:18:07.912" v="4225" actId="113"/>
-          <ac:spMkLst>
-            <pc:docMk/>
-            <pc:sldMk cId="3569115401" sldId="277"/>
-            <ac:spMk id="10" creationId="{2782DDC2-3454-2C0E-4160-3EA12671CE87}"/>
-          </ac:spMkLst>
-        </pc:spChg>
-        <pc:graphicFrameChg chg="mod modGraphic">
-          <ac:chgData name="耀泉 马" userId="19e30af8d5659de2" providerId="LiveId" clId="{C3594856-CEDA-5129-B2AF-7962E3CA4CA3}" dt="2026-07-14T08:20:02.751" v="4232" actId="20577"/>
-          <ac:graphicFrameMkLst>
-            <pc:docMk/>
-            <pc:sldMk cId="3569115401" sldId="277"/>
-            <ac:graphicFrameMk id="7" creationId="{9AE4D1DA-C2BF-AF62-6479-1326E9C900A6}"/>
-          </ac:graphicFrameMkLst>
-        </pc:graphicFrameChg>
-      </pc:sldChg>
-      <pc:sldChg chg="addSp delSp modSp new mod">
-        <pc:chgData name="耀泉 马" userId="19e30af8d5659de2" providerId="LiveId" clId="{C3594856-CEDA-5129-B2AF-7962E3CA4CA3}" dt="2026-07-14T08:28:21.916" v="4367" actId="1076"/>
-        <pc:sldMkLst>
-          <pc:docMk/>
-          <pc:sldMk cId="1153154203" sldId="278"/>
-        </pc:sldMkLst>
-        <pc:spChg chg="mod">
-          <ac:chgData name="耀泉 马" userId="19e30af8d5659de2" providerId="LiveId" clId="{C3594856-CEDA-5129-B2AF-7962E3CA4CA3}" dt="2026-07-14T08:21:51.532" v="4236" actId="27636"/>
-          <ac:spMkLst>
-            <pc:docMk/>
-            <pc:sldMk cId="1153154203" sldId="278"/>
-            <ac:spMk id="2" creationId="{8E14B777-5CE5-0CCD-FCB6-D2CE0D8EFE59}"/>
-          </ac:spMkLst>
-        </pc:spChg>
-        <pc:spChg chg="add mod">
-          <ac:chgData name="耀泉 马" userId="19e30af8d5659de2" providerId="LiveId" clId="{C3594856-CEDA-5129-B2AF-7962E3CA4CA3}" dt="2026-07-14T08:28:21.916" v="4367" actId="1076"/>
-          <ac:spMkLst>
-            <pc:docMk/>
-            <pc:sldMk cId="1153154203" sldId="278"/>
-            <ac:spMk id="5" creationId="{854D5AB6-5554-AA65-B260-AA01CAB70968}"/>
-          </ac:spMkLst>
-        </pc:spChg>
-        <pc:graphicFrameChg chg="add mod ord modGraphic">
-          <ac:chgData name="耀泉 马" userId="19e30af8d5659de2" providerId="LiveId" clId="{C3594856-CEDA-5129-B2AF-7962E3CA4CA3}" dt="2026-07-14T08:28:21.916" v="4367" actId="1076"/>
-          <ac:graphicFrameMkLst>
-            <pc:docMk/>
-            <pc:sldMk cId="1153154203" sldId="278"/>
-            <ac:graphicFrameMk id="4" creationId="{3C9C272F-6B61-5CED-59DF-B0F03E460CA5}"/>
-          </ac:graphicFrameMkLst>
-        </pc:graphicFrameChg>
-      </pc:sldChg>
       <pc:sldChg chg="modSp add mod">
-        <pc:chgData name="耀泉 马" userId="19e30af8d5659de2" providerId="LiveId" clId="{C3594856-CEDA-5129-B2AF-7962E3CA4CA3}" dt="2026-07-14T13:07:09.301" v="5574" actId="207"/>
+        <pc:chgData name="耀泉 马" userId="19e30af8d5659de2" providerId="LiveId" clId="{C3594856-CEDA-5129-B2AF-7962E3CA4CA3}" dt="2026-08-14T15:38:38.617" v="7017" actId="20578"/>
         <pc:sldMkLst>
           <pc:docMk/>
           <pc:sldMk cId="2295956662" sldId="280"/>
         </pc:sldMkLst>
         <pc:spChg chg="mod">
-          <ac:chgData name="耀泉 马" userId="19e30af8d5659de2" providerId="LiveId" clId="{C3594856-CEDA-5129-B2AF-7962E3CA4CA3}" dt="2026-07-14T09:44:56.073" v="5128" actId="20577"/>
+          <ac:chgData name="耀泉 马" userId="19e30af8d5659de2" providerId="LiveId" clId="{C3594856-CEDA-5129-B2AF-7962E3CA4CA3}" dt="2026-08-14T15:38:38.617" v="7017" actId="20578"/>
           <ac:spMkLst>
             <pc:docMk/>
             <pc:sldMk cId="2295956662" sldId="280"/>
-            <ac:spMk id="2" creationId="{3FFDBD42-7200-B2AB-5CCE-0FDA77E99B8D}"/>
-          </ac:spMkLst>
-        </pc:spChg>
-        <pc:spChg chg="mod">
-          <ac:chgData name="耀泉 马" userId="19e30af8d5659de2" providerId="LiveId" clId="{C3594856-CEDA-5129-B2AF-7962E3CA4CA3}" dt="2026-07-14T13:06:46.473" v="5567" actId="1076"/>
-          <ac:spMkLst>
-            <pc:docMk/>
-            <pc:sldMk cId="2295956662" sldId="280"/>
-            <ac:spMk id="6" creationId="{0FF83E2A-7C68-54DE-B160-A2ED748F8B53}"/>
-          </ac:spMkLst>
-        </pc:spChg>
-        <pc:spChg chg="mod">
-          <ac:chgData name="耀泉 马" userId="19e30af8d5659de2" providerId="LiveId" clId="{C3594856-CEDA-5129-B2AF-7962E3CA4CA3}" dt="2026-07-14T13:07:09.301" v="5574" actId="207"/>
-          <ac:spMkLst>
-            <pc:docMk/>
-            <pc:sldMk cId="2295956662" sldId="280"/>
-            <ac:spMk id="7" creationId="{5437312F-9822-4016-0C0E-4FC88E5A6129}"/>
-          </ac:spMkLst>
-        </pc:spChg>
-        <pc:graphicFrameChg chg="mod">
-          <ac:chgData name="耀泉 马" userId="19e30af8d5659de2" providerId="LiveId" clId="{C3594856-CEDA-5129-B2AF-7962E3CA4CA3}" dt="2026-07-14T09:37:46.339" v="5116" actId="1076"/>
-          <ac:graphicFrameMkLst>
-            <pc:docMk/>
-            <pc:sldMk cId="2295956662" sldId="280"/>
-            <ac:graphicFrameMk id="4" creationId="{5EEF5B49-0B54-A282-0F5F-AF9D79D04AC3}"/>
-          </ac:graphicFrameMkLst>
-        </pc:graphicFrameChg>
-      </pc:sldChg>
-      <pc:sldChg chg="modSp add mod">
-        <pc:chgData name="耀泉 马" userId="19e30af8d5659de2" providerId="LiveId" clId="{C3594856-CEDA-5129-B2AF-7962E3CA4CA3}" dt="2026-07-14T13:13:48.783" v="5958" actId="20577"/>
-        <pc:sldMkLst>
-          <pc:docMk/>
-          <pc:sldMk cId="1724624362" sldId="282"/>
-        </pc:sldMkLst>
-        <pc:spChg chg="mod">
-          <ac:chgData name="耀泉 马" userId="19e30af8d5659de2" providerId="LiveId" clId="{C3594856-CEDA-5129-B2AF-7962E3CA4CA3}" dt="2026-07-14T13:13:48.783" v="5958" actId="20577"/>
-          <ac:spMkLst>
-            <pc:docMk/>
-            <pc:sldMk cId="1724624362" sldId="282"/>
-            <ac:spMk id="2" creationId="{5F34850A-79F2-A6E3-48D1-B01CDFA35D24}"/>
-          </ac:spMkLst>
-        </pc:spChg>
-        <pc:graphicFrameChg chg="mod modGraphic">
-          <ac:chgData name="耀泉 马" userId="19e30af8d5659de2" providerId="LiveId" clId="{C3594856-CEDA-5129-B2AF-7962E3CA4CA3}" dt="2026-07-14T12:12:52.594" v="5326"/>
-          <ac:graphicFrameMkLst>
-            <pc:docMk/>
-            <pc:sldMk cId="1724624362" sldId="282"/>
-            <ac:graphicFrameMk id="10" creationId="{EAC0C4C5-BB83-2835-3ACC-3FACC66EFC6E}"/>
-          </ac:graphicFrameMkLst>
-        </pc:graphicFrameChg>
-      </pc:sldChg>
-      <pc:sldChg chg="addSp delSp modSp add mod">
-        <pc:chgData name="耀泉 马" userId="19e30af8d5659de2" providerId="LiveId" clId="{C3594856-CEDA-5129-B2AF-7962E3CA4CA3}" dt="2026-07-14T13:13:45.440" v="5954" actId="20577"/>
-        <pc:sldMkLst>
-          <pc:docMk/>
-          <pc:sldMk cId="1206957868" sldId="284"/>
-        </pc:sldMkLst>
-        <pc:spChg chg="mod">
-          <ac:chgData name="耀泉 马" userId="19e30af8d5659de2" providerId="LiveId" clId="{C3594856-CEDA-5129-B2AF-7962E3CA4CA3}" dt="2026-07-14T13:13:45.440" v="5954" actId="20577"/>
-          <ac:spMkLst>
-            <pc:docMk/>
-            <pc:sldMk cId="1206957868" sldId="284"/>
-            <ac:spMk id="2" creationId="{79049FFC-C865-C239-D28E-C52D2B741C40}"/>
-          </ac:spMkLst>
-        </pc:spChg>
-        <pc:spChg chg="add mod">
-          <ac:chgData name="耀泉 马" userId="19e30af8d5659de2" providerId="LiveId" clId="{C3594856-CEDA-5129-B2AF-7962E3CA4CA3}" dt="2026-07-14T12:32:34.538" v="5538" actId="207"/>
-          <ac:spMkLst>
-            <pc:docMk/>
-            <pc:sldMk cId="1206957868" sldId="284"/>
-            <ac:spMk id="7" creationId="{5548FEC0-4B20-E6F5-0355-400A6A3EE212}"/>
-          </ac:spMkLst>
-        </pc:spChg>
-        <pc:graphicFrameChg chg="add mod ord modGraphic">
-          <ac:chgData name="耀泉 马" userId="19e30af8d5659de2" providerId="LiveId" clId="{C3594856-CEDA-5129-B2AF-7962E3CA4CA3}" dt="2026-07-14T12:27:24.414" v="5512" actId="1076"/>
-          <ac:graphicFrameMkLst>
-            <pc:docMk/>
-            <pc:sldMk cId="1206957868" sldId="284"/>
-            <ac:graphicFrameMk id="6" creationId="{A8853277-54F8-F7FD-3911-02BDAAD61906}"/>
-          </ac:graphicFrameMkLst>
-        </pc:graphicFrameChg>
-      </pc:sldChg>
-      <pc:sldChg chg="addSp delSp modSp add mod">
-        <pc:chgData name="耀泉 马" userId="19e30af8d5659de2" providerId="LiveId" clId="{C3594856-CEDA-5129-B2AF-7962E3CA4CA3}" dt="2026-07-14T14:00:46.376" v="6296" actId="1076"/>
-        <pc:sldMkLst>
-          <pc:docMk/>
-          <pc:sldMk cId="1696916202" sldId="285"/>
-        </pc:sldMkLst>
-        <pc:spChg chg="mod">
-          <ac:chgData name="耀泉 马" userId="19e30af8d5659de2" providerId="LiveId" clId="{C3594856-CEDA-5129-B2AF-7962E3CA4CA3}" dt="2026-07-14T13:59:30.571" v="6284" actId="27636"/>
-          <ac:spMkLst>
-            <pc:docMk/>
-            <pc:sldMk cId="1696916202" sldId="285"/>
-            <ac:spMk id="2" creationId="{B0ADC4F9-2455-C5FA-294C-03DF991C15F5}"/>
-          </ac:spMkLst>
-        </pc:spChg>
-        <pc:spChg chg="mod">
-          <ac:chgData name="耀泉 马" userId="19e30af8d5659de2" providerId="LiveId" clId="{C3594856-CEDA-5129-B2AF-7962E3CA4CA3}" dt="2026-07-14T13:15:35.236" v="5961" actId="20577"/>
-          <ac:spMkLst>
-            <pc:docMk/>
-            <pc:sldMk cId="1696916202" sldId="285"/>
-            <ac:spMk id="7" creationId="{F59E775D-1005-D65D-954B-C79D7C759849}"/>
-          </ac:spMkLst>
-        </pc:spChg>
-        <pc:spChg chg="add mod">
-          <ac:chgData name="耀泉 马" userId="19e30af8d5659de2" providerId="LiveId" clId="{C3594856-CEDA-5129-B2AF-7962E3CA4CA3}" dt="2026-07-14T13:54:21.497" v="6260" actId="20577"/>
-          <ac:spMkLst>
-            <pc:docMk/>
-            <pc:sldMk cId="1696916202" sldId="285"/>
-            <ac:spMk id="14" creationId="{D45A383D-E512-1FE8-48E1-8FA102A4E480}"/>
-          </ac:spMkLst>
-        </pc:spChg>
-        <pc:spChg chg="add mod">
-          <ac:chgData name="耀泉 马" userId="19e30af8d5659de2" providerId="LiveId" clId="{C3594856-CEDA-5129-B2AF-7962E3CA4CA3}" dt="2026-07-14T13:59:18.312" v="6280" actId="207"/>
-          <ac:spMkLst>
-            <pc:docMk/>
-            <pc:sldMk cId="1696916202" sldId="285"/>
-            <ac:spMk id="16" creationId="{93B46C9D-E260-2EFB-C07A-9E2DF89FF9F4}"/>
-          </ac:spMkLst>
-        </pc:spChg>
-        <pc:spChg chg="add mod">
-          <ac:chgData name="耀泉 马" userId="19e30af8d5659de2" providerId="LiveId" clId="{C3594856-CEDA-5129-B2AF-7962E3CA4CA3}" dt="2026-07-14T13:59:52.104" v="6288" actId="14100"/>
-          <ac:spMkLst>
-            <pc:docMk/>
-            <pc:sldMk cId="1696916202" sldId="285"/>
-            <ac:spMk id="18" creationId="{80DA7CCB-390E-2F3C-DF7D-57CB36497849}"/>
-          </ac:spMkLst>
-        </pc:spChg>
-        <pc:spChg chg="add mod">
-          <ac:chgData name="耀泉 马" userId="19e30af8d5659de2" providerId="LiveId" clId="{C3594856-CEDA-5129-B2AF-7962E3CA4CA3}" dt="2026-07-14T14:00:46.376" v="6296" actId="1076"/>
-          <ac:spMkLst>
-            <pc:docMk/>
-            <pc:sldMk cId="1696916202" sldId="285"/>
-            <ac:spMk id="19" creationId="{5AD177FC-AA4B-067A-0FBF-8931A465CC0F}"/>
-          </ac:spMkLst>
-        </pc:spChg>
-        <pc:graphicFrameChg chg="add mod ord modGraphic">
-          <ac:chgData name="耀泉 马" userId="19e30af8d5659de2" providerId="LiveId" clId="{C3594856-CEDA-5129-B2AF-7962E3CA4CA3}" dt="2026-07-14T13:57:12.412" v="6274" actId="1076"/>
-          <ac:graphicFrameMkLst>
-            <pc:docMk/>
-            <pc:sldMk cId="1696916202" sldId="285"/>
-            <ac:graphicFrameMk id="5" creationId="{9CCB1254-C9EF-0805-3B3C-121C5080A25C}"/>
-          </ac:graphicFrameMkLst>
-        </pc:graphicFrameChg>
-      </pc:sldChg>
-      <pc:sldChg chg="modSp new mod">
-        <pc:chgData name="耀泉 马" userId="19e30af8d5659de2" providerId="LiveId" clId="{C3594856-CEDA-5129-B2AF-7962E3CA4CA3}" dt="2026-07-14T13:13:26.865" v="5948" actId="20577"/>
-        <pc:sldMkLst>
-          <pc:docMk/>
-          <pc:sldMk cId="1114094049" sldId="286"/>
-        </pc:sldMkLst>
-        <pc:spChg chg="mod">
-          <ac:chgData name="耀泉 马" userId="19e30af8d5659de2" providerId="LiveId" clId="{C3594856-CEDA-5129-B2AF-7962E3CA4CA3}" dt="2026-07-14T13:13:26.865" v="5948" actId="20577"/>
-          <ac:spMkLst>
-            <pc:docMk/>
-            <pc:sldMk cId="1114094049" sldId="286"/>
-            <ac:spMk id="2" creationId="{0E88FDC7-3545-9B75-5908-B8B4DD480DF5}"/>
-          </ac:spMkLst>
-        </pc:spChg>
-        <pc:spChg chg="mod">
-          <ac:chgData name="耀泉 马" userId="19e30af8d5659de2" providerId="LiveId" clId="{C3594856-CEDA-5129-B2AF-7962E3CA4CA3}" dt="2026-07-14T13:13:19.819" v="5947" actId="12"/>
-          <ac:spMkLst>
-            <pc:docMk/>
-            <pc:sldMk cId="1114094049" sldId="286"/>
-            <ac:spMk id="3" creationId="{78148556-AE8F-8E01-68C9-D68E61DB2A29}"/>
+            <ac:spMk id="3" creationId="{FA906C82-57DA-709E-2D93-27093FC5C3D9}"/>
           </ac:spMkLst>
         </pc:spChg>
       </pc:sldChg>
@@ -1042,14 +207,6 @@
           <pc:docMk/>
           <pc:sldMk cId="650267645" sldId="287"/>
         </pc:sldMkLst>
-        <pc:spChg chg="mod">
-          <ac:chgData name="耀泉 马" userId="19e30af8d5659de2" providerId="LiveId" clId="{C3594856-CEDA-5129-B2AF-7962E3CA4CA3}" dt="2026-07-14T14:59:58.803" v="6298"/>
-          <ac:spMkLst>
-            <pc:docMk/>
-            <pc:sldMk cId="650267645" sldId="287"/>
-            <ac:spMk id="2" creationId="{494EC17A-CF62-99FE-491F-6B612FD1B6BA}"/>
-          </ac:spMkLst>
-        </pc:spChg>
         <pc:spChg chg="mod">
           <ac:chgData name="耀泉 马" userId="19e30af8d5659de2" providerId="LiveId" clId="{C3594856-CEDA-5129-B2AF-7962E3CA4CA3}" dt="2026-07-21T14:58:53.795" v="6941" actId="113"/>
           <ac:spMkLst>
@@ -1146,7 +303,7 @@
           <a:p>
             <a:fld id="{31DEB800-E523-5842-ADA5-667D03D4DDAE}" type="datetimeFigureOut">
               <a:rPr lang="en-US" smtClean="0"/>
-              <a:t>7/21/26</a:t>
+              <a:t>8/14/26</a:t>
             </a:fld>
             <a:endParaRPr lang="en-US"/>
           </a:p>
@@ -3928,7 +3085,7 @@
           <a:p>
             <a:fld id="{D13D43DF-0D0E-F847-A925-24D8FAA785A6}" type="datetimeFigureOut">
               <a:rPr lang="en-US" smtClean="0"/>
-              <a:t>7/21/26</a:t>
+              <a:t>8/14/26</a:t>
             </a:fld>
             <a:endParaRPr lang="en-US"/>
           </a:p>
@@ -4128,7 +3285,7 @@
           <a:p>
             <a:fld id="{D13D43DF-0D0E-F847-A925-24D8FAA785A6}" type="datetimeFigureOut">
               <a:rPr lang="en-US" smtClean="0"/>
-              <a:t>7/21/26</a:t>
+              <a:t>8/14/26</a:t>
             </a:fld>
             <a:endParaRPr lang="en-US"/>
           </a:p>
@@ -4338,7 +3495,7 @@
           <a:p>
             <a:fld id="{D13D43DF-0D0E-F847-A925-24D8FAA785A6}" type="datetimeFigureOut">
               <a:rPr lang="en-US" smtClean="0"/>
-              <a:t>7/21/26</a:t>
+              <a:t>8/14/26</a:t>
             </a:fld>
             <a:endParaRPr lang="en-US"/>
           </a:p>
@@ -4538,7 +3695,7 @@
           <a:p>
             <a:fld id="{D13D43DF-0D0E-F847-A925-24D8FAA785A6}" type="datetimeFigureOut">
               <a:rPr lang="en-US" smtClean="0"/>
-              <a:t>7/21/26</a:t>
+              <a:t>8/14/26</a:t>
             </a:fld>
             <a:endParaRPr lang="en-US"/>
           </a:p>
@@ -4814,7 +3971,7 @@
           <a:p>
             <a:fld id="{D13D43DF-0D0E-F847-A925-24D8FAA785A6}" type="datetimeFigureOut">
               <a:rPr lang="en-US" smtClean="0"/>
-              <a:t>7/21/26</a:t>
+              <a:t>8/14/26</a:t>
             </a:fld>
             <a:endParaRPr lang="en-US"/>
           </a:p>
@@ -5082,7 +4239,7 @@
           <a:p>
             <a:fld id="{D13D43DF-0D0E-F847-A925-24D8FAA785A6}" type="datetimeFigureOut">
               <a:rPr lang="en-US" smtClean="0"/>
-              <a:t>7/21/26</a:t>
+              <a:t>8/14/26</a:t>
             </a:fld>
             <a:endParaRPr lang="en-US"/>
           </a:p>
@@ -5497,7 +4654,7 @@
           <a:p>
             <a:fld id="{D13D43DF-0D0E-F847-A925-24D8FAA785A6}" type="datetimeFigureOut">
               <a:rPr lang="en-US" smtClean="0"/>
-              <a:t>7/21/26</a:t>
+              <a:t>8/14/26</a:t>
             </a:fld>
             <a:endParaRPr lang="en-US"/>
           </a:p>
@@ -5639,7 +4796,7 @@
           <a:p>
             <a:fld id="{D13D43DF-0D0E-F847-A925-24D8FAA785A6}" type="datetimeFigureOut">
               <a:rPr lang="en-US" smtClean="0"/>
-              <a:t>7/21/26</a:t>
+              <a:t>8/14/26</a:t>
             </a:fld>
             <a:endParaRPr lang="en-US"/>
           </a:p>
@@ -5752,7 +4909,7 @@
           <a:p>
             <a:fld id="{D13D43DF-0D0E-F847-A925-24D8FAA785A6}" type="datetimeFigureOut">
               <a:rPr lang="en-US" smtClean="0"/>
-              <a:t>7/21/26</a:t>
+              <a:t>8/14/26</a:t>
             </a:fld>
             <a:endParaRPr lang="en-US"/>
           </a:p>
@@ -6065,7 +5222,7 @@
           <a:p>
             <a:fld id="{D13D43DF-0D0E-F847-A925-24D8FAA785A6}" type="datetimeFigureOut">
               <a:rPr lang="en-US" smtClean="0"/>
-              <a:t>7/21/26</a:t>
+              <a:t>8/14/26</a:t>
             </a:fld>
             <a:endParaRPr lang="en-US"/>
           </a:p>
@@ -6354,7 +5511,7 @@
           <a:p>
             <a:fld id="{D13D43DF-0D0E-F847-A925-24D8FAA785A6}" type="datetimeFigureOut">
               <a:rPr lang="en-US" smtClean="0"/>
-              <a:t>7/21/26</a:t>
+              <a:t>8/14/26</a:t>
             </a:fld>
             <a:endParaRPr lang="en-US"/>
           </a:p>
@@ -6597,7 +5754,7 @@
           <a:p>
             <a:fld id="{D13D43DF-0D0E-F847-A925-24D8FAA785A6}" type="datetimeFigureOut">
               <a:rPr lang="en-US" smtClean="0"/>
-              <a:t>7/21/26</a:t>
+              <a:t>8/14/26</a:t>
             </a:fld>
             <a:endParaRPr lang="en-US"/>
           </a:p>
@@ -7135,7 +6292,7 @@
             <p:ph idx="1"/>
             <p:extLst>
               <p:ext uri="{D42A27DB-BD31-4B8C-83A1-F6EECF244321}">
-                <p14:modId xmlns:p14="http://schemas.microsoft.com/office/powerpoint/2010/main" val="88779050"/>
+                <p14:modId xmlns:p14="http://schemas.microsoft.com/office/powerpoint/2010/main" val="658037903"/>
               </p:ext>
             </p:extLst>
           </p:nvPr>
@@ -7246,7 +6403,7 @@
                             <a:schemeClr val="tx1"/>
                           </a:solidFill>
                         </a:rPr>
-                        <a:t>no-TDX</a:t>
+                        <a:t>Normal</a:t>
                       </a:r>
                     </a:p>
                   </a:txBody>
@@ -17157,11 +16314,19 @@
           <a:p>
             <a:r>
               <a:rPr lang="en-US" sz="2000" b="1"/>
-              <a:t>Autoregressive decoding: </a:t>
+              <a:t>decoding: </a:t>
             </a:r>
             <a:r>
               <a:rPr lang="en-US" sz="2000"/>
-              <a:t>generates tokens iteratively until EOS or the maximum token limit is reached.</a:t>
+              <a:t>generates tokens iteratively until EOS or the maximum token limit is re</a:t>
+            </a:r>
+            <a:r>
+              <a:rPr lang="en-US" sz="2000" b="1"/>
+              <a:t>Autoregressive</a:t>
+            </a:r>
+            <a:r>
+              <a:rPr lang="en-US" sz="2000"/>
+              <a:t>ached.</a:t>
             </a:r>
           </a:p>
           <a:p>

</xml_diff>